<commit_message>
update based on feedback
</commit_message>
<xml_diff>
--- a/figures/ch1/ch1_figures.pptx
+++ b/figures/ch1/ch1_figures.pptx
@@ -5,10 +5,13 @@
     <p:sldMasterId id="2147483648" r:id="rId1"/>
   </p:sldMasterIdLst>
   <p:sldIdLst>
-    <p:sldId id="256" r:id="rId2"/>
-    <p:sldId id="261" r:id="rId3"/>
-    <p:sldId id="258" r:id="rId4"/>
-    <p:sldId id="259" r:id="rId5"/>
+    <p:sldId id="264" r:id="rId2"/>
+    <p:sldId id="256" r:id="rId3"/>
+    <p:sldId id="267" r:id="rId4"/>
+    <p:sldId id="266" r:id="rId5"/>
+    <p:sldId id="268" r:id="rId6"/>
+    <p:sldId id="261" r:id="rId7"/>
+    <p:sldId id="262" r:id="rId8"/>
   </p:sldIdLst>
   <p:sldSz cx="12192000" cy="6858000"/>
   <p:notesSz cx="6858000" cy="9144000"/>
@@ -262,7 +265,7 @@
           <a:p>
             <a:fld id="{6AECCEE4-E404-41DF-89A3-E64313283A40}" type="datetimeFigureOut">
               <a:rPr lang="en-US" smtClean="0"/>
-              <a:t>6/23/2026</a:t>
+              <a:t>7/6/2026</a:t>
             </a:fld>
             <a:endParaRPr lang="en-US"/>
           </a:p>
@@ -460,7 +463,7 @@
           <a:p>
             <a:fld id="{6AECCEE4-E404-41DF-89A3-E64313283A40}" type="datetimeFigureOut">
               <a:rPr lang="en-US" smtClean="0"/>
-              <a:t>6/23/2026</a:t>
+              <a:t>7/6/2026</a:t>
             </a:fld>
             <a:endParaRPr lang="en-US"/>
           </a:p>
@@ -668,7 +671,7 @@
           <a:p>
             <a:fld id="{6AECCEE4-E404-41DF-89A3-E64313283A40}" type="datetimeFigureOut">
               <a:rPr lang="en-US" smtClean="0"/>
-              <a:t>6/23/2026</a:t>
+              <a:t>7/6/2026</a:t>
             </a:fld>
             <a:endParaRPr lang="en-US"/>
           </a:p>
@@ -866,7 +869,7 @@
           <a:p>
             <a:fld id="{6AECCEE4-E404-41DF-89A3-E64313283A40}" type="datetimeFigureOut">
               <a:rPr lang="en-US" smtClean="0"/>
-              <a:t>6/23/2026</a:t>
+              <a:t>7/6/2026</a:t>
             </a:fld>
             <a:endParaRPr lang="en-US"/>
           </a:p>
@@ -1141,7 +1144,7 @@
           <a:p>
             <a:fld id="{6AECCEE4-E404-41DF-89A3-E64313283A40}" type="datetimeFigureOut">
               <a:rPr lang="en-US" smtClean="0"/>
-              <a:t>6/23/2026</a:t>
+              <a:t>7/6/2026</a:t>
             </a:fld>
             <a:endParaRPr lang="en-US"/>
           </a:p>
@@ -1406,7 +1409,7 @@
           <a:p>
             <a:fld id="{6AECCEE4-E404-41DF-89A3-E64313283A40}" type="datetimeFigureOut">
               <a:rPr lang="en-US" smtClean="0"/>
-              <a:t>6/23/2026</a:t>
+              <a:t>7/6/2026</a:t>
             </a:fld>
             <a:endParaRPr lang="en-US"/>
           </a:p>
@@ -1818,7 +1821,7 @@
           <a:p>
             <a:fld id="{6AECCEE4-E404-41DF-89A3-E64313283A40}" type="datetimeFigureOut">
               <a:rPr lang="en-US" smtClean="0"/>
-              <a:t>6/23/2026</a:t>
+              <a:t>7/6/2026</a:t>
             </a:fld>
             <a:endParaRPr lang="en-US"/>
           </a:p>
@@ -1959,7 +1962,7 @@
           <a:p>
             <a:fld id="{6AECCEE4-E404-41DF-89A3-E64313283A40}" type="datetimeFigureOut">
               <a:rPr lang="en-US" smtClean="0"/>
-              <a:t>6/23/2026</a:t>
+              <a:t>7/6/2026</a:t>
             </a:fld>
             <a:endParaRPr lang="en-US"/>
           </a:p>
@@ -2072,7 +2075,7 @@
           <a:p>
             <a:fld id="{6AECCEE4-E404-41DF-89A3-E64313283A40}" type="datetimeFigureOut">
               <a:rPr lang="en-US" smtClean="0"/>
-              <a:t>6/23/2026</a:t>
+              <a:t>7/6/2026</a:t>
             </a:fld>
             <a:endParaRPr lang="en-US"/>
           </a:p>
@@ -2383,7 +2386,7 @@
           <a:p>
             <a:fld id="{6AECCEE4-E404-41DF-89A3-E64313283A40}" type="datetimeFigureOut">
               <a:rPr lang="en-US" smtClean="0"/>
-              <a:t>6/23/2026</a:t>
+              <a:t>7/6/2026</a:t>
             </a:fld>
             <a:endParaRPr lang="en-US"/>
           </a:p>
@@ -2671,7 +2674,7 @@
           <a:p>
             <a:fld id="{6AECCEE4-E404-41DF-89A3-E64313283A40}" type="datetimeFigureOut">
               <a:rPr lang="en-US" smtClean="0"/>
-              <a:t>6/23/2026</a:t>
+              <a:t>7/6/2026</a:t>
             </a:fld>
             <a:endParaRPr lang="en-US"/>
           </a:p>
@@ -2912,7 +2915,7 @@
           <a:p>
             <a:fld id="{6AECCEE4-E404-41DF-89A3-E64313283A40}" type="datetimeFigureOut">
               <a:rPr lang="en-US" smtClean="0"/>
-              <a:t>6/23/2026</a:t>
+              <a:t>7/6/2026</a:t>
             </a:fld>
             <a:endParaRPr lang="en-US"/>
           </a:p>
@@ -3317,7 +3320,13 @@
   <p:cSld>
     <p:spTree>
       <p:nvGrpSpPr>
-        <p:cNvPr id="1" name=""/>
+        <p:cNvPr id="1" name="">
+          <a:extLst>
+            <a:ext uri="{FF2B5EF4-FFF2-40B4-BE49-F238E27FC236}">
+              <a16:creationId xmlns:a16="http://schemas.microsoft.com/office/drawing/2014/main" id="{E7DBBA81-8FD2-0B7B-26AF-0DBABA811A92}"/>
+            </a:ext>
+          </a:extLst>
+        </p:cNvPr>
         <p:cNvGrpSpPr/>
         <p:nvPr/>
       </p:nvGrpSpPr>
@@ -3331,10 +3340,10 @@
       </p:grpSpPr>
       <p:pic>
         <p:nvPicPr>
-          <p:cNvPr id="5" name="Picture 4">
-            <a:extLst>
-              <a:ext uri="{FF2B5EF4-FFF2-40B4-BE49-F238E27FC236}">
-                <a16:creationId xmlns:a16="http://schemas.microsoft.com/office/drawing/2014/main" id="{624C2831-F414-94BA-31E7-62CDCAFC71F5}"/>
+          <p:cNvPr id="9" name="Picture 8">
+            <a:extLst>
+              <a:ext uri="{FF2B5EF4-FFF2-40B4-BE49-F238E27FC236}">
+                <a16:creationId xmlns:a16="http://schemas.microsoft.com/office/drawing/2014/main" id="{2B8C65E8-994D-D09E-A1C0-9720E4303105}"/>
               </a:ext>
             </a:extLst>
           </p:cNvPr>
@@ -3357,20 +3366,304 @@
         </p:blipFill>
         <p:spPr>
           <a:xfrm>
-            <a:off x="169720" y="1398984"/>
-            <a:ext cx="11816515" cy="3938838"/>
+            <a:off x="2561733" y="804496"/>
+            <a:ext cx="7049484" cy="5249008"/>
           </a:xfrm>
           <a:prstGeom prst="rect">
             <a:avLst/>
           </a:prstGeom>
         </p:spPr>
       </p:pic>
+      <p:cxnSp>
+        <p:nvCxnSpPr>
+          <p:cNvPr id="5" name="Straight Connector 4">
+            <a:extLst>
+              <a:ext uri="{FF2B5EF4-FFF2-40B4-BE49-F238E27FC236}">
+                <a16:creationId xmlns:a16="http://schemas.microsoft.com/office/drawing/2014/main" id="{407E2A8A-FC9A-C275-50D3-F79A208DD983}"/>
+              </a:ext>
+            </a:extLst>
+          </p:cNvPr>
+          <p:cNvCxnSpPr>
+            <a:cxnSpLocks/>
+          </p:cNvCxnSpPr>
+          <p:nvPr/>
+        </p:nvCxnSpPr>
+        <p:spPr>
+          <a:xfrm>
+            <a:off x="4314825" y="1162050"/>
+            <a:ext cx="3543300" cy="0"/>
+          </a:xfrm>
+          <a:prstGeom prst="line">
+            <a:avLst/>
+          </a:prstGeom>
+          <a:ln w="9525"/>
+        </p:spPr>
+        <p:style>
+          <a:lnRef idx="2">
+            <a:schemeClr val="dk1"/>
+          </a:lnRef>
+          <a:fillRef idx="0">
+            <a:schemeClr val="dk1"/>
+          </a:fillRef>
+          <a:effectRef idx="1">
+            <a:schemeClr val="dk1"/>
+          </a:effectRef>
+          <a:fontRef idx="minor">
+            <a:schemeClr val="tx1"/>
+          </a:fontRef>
+        </p:style>
+      </p:cxnSp>
+      <p:cxnSp>
+        <p:nvCxnSpPr>
+          <p:cNvPr id="6" name="Straight Connector 5">
+            <a:extLst>
+              <a:ext uri="{FF2B5EF4-FFF2-40B4-BE49-F238E27FC236}">
+                <a16:creationId xmlns:a16="http://schemas.microsoft.com/office/drawing/2014/main" id="{BCCA907A-0918-3B99-40ED-9A115A0ED13F}"/>
+              </a:ext>
+            </a:extLst>
+          </p:cNvPr>
+          <p:cNvCxnSpPr>
+            <a:cxnSpLocks/>
+          </p:cNvCxnSpPr>
+          <p:nvPr/>
+        </p:nvCxnSpPr>
+        <p:spPr>
+          <a:xfrm>
+            <a:off x="7858125" y="1162050"/>
+            <a:ext cx="0" cy="4524375"/>
+          </a:xfrm>
+          <a:prstGeom prst="line">
+            <a:avLst/>
+          </a:prstGeom>
+          <a:ln w="9525"/>
+        </p:spPr>
+        <p:style>
+          <a:lnRef idx="2">
+            <a:schemeClr val="dk1"/>
+          </a:lnRef>
+          <a:fillRef idx="0">
+            <a:schemeClr val="dk1"/>
+          </a:fillRef>
+          <a:effectRef idx="1">
+            <a:schemeClr val="dk1"/>
+          </a:effectRef>
+          <a:fontRef idx="minor">
+            <a:schemeClr val="tx1"/>
+          </a:fontRef>
+        </p:style>
+      </p:cxnSp>
+      <p:sp>
+        <p:nvSpPr>
+          <p:cNvPr id="10" name="Rectangle 9">
+            <a:extLst>
+              <a:ext uri="{FF2B5EF4-FFF2-40B4-BE49-F238E27FC236}">
+                <a16:creationId xmlns:a16="http://schemas.microsoft.com/office/drawing/2014/main" id="{C854AA11-79F1-605E-C19F-E0886EBEBED6}"/>
+              </a:ext>
+            </a:extLst>
+          </p:cNvPr>
+          <p:cNvSpPr/>
+          <p:nvPr/>
+        </p:nvSpPr>
+        <p:spPr>
+          <a:xfrm>
+            <a:off x="3676650" y="5680048"/>
+            <a:ext cx="628650" cy="371470"/>
+          </a:xfrm>
+          <a:prstGeom prst="rect">
+            <a:avLst/>
+          </a:prstGeom>
+          <a:solidFill>
+            <a:schemeClr val="bg1"/>
+          </a:solidFill>
+          <a:ln>
+            <a:solidFill>
+              <a:schemeClr val="bg1"/>
+            </a:solidFill>
+          </a:ln>
+        </p:spPr>
+        <p:style>
+          <a:lnRef idx="2">
+            <a:schemeClr val="accent6"/>
+          </a:lnRef>
+          <a:fillRef idx="1">
+            <a:schemeClr val="lt1"/>
+          </a:fillRef>
+          <a:effectRef idx="0">
+            <a:schemeClr val="accent6"/>
+          </a:effectRef>
+          <a:fontRef idx="minor">
+            <a:schemeClr val="dk1"/>
+          </a:fontRef>
+        </p:style>
+        <p:txBody>
+          <a:bodyPr rtlCol="0" anchor="ctr"/>
+          <a:lstStyle/>
+          <a:p>
+            <a:pPr algn="ctr"/>
+            <a:endParaRPr lang="en-US"/>
+          </a:p>
+        </p:txBody>
+      </p:sp>
+      <p:sp>
+        <p:nvSpPr>
+          <p:cNvPr id="11" name="Rectangle 10">
+            <a:extLst>
+              <a:ext uri="{FF2B5EF4-FFF2-40B4-BE49-F238E27FC236}">
+                <a16:creationId xmlns:a16="http://schemas.microsoft.com/office/drawing/2014/main" id="{84E05676-7773-692C-23BE-CF512B93F71B}"/>
+              </a:ext>
+            </a:extLst>
+          </p:cNvPr>
+          <p:cNvSpPr/>
+          <p:nvPr/>
+        </p:nvSpPr>
+        <p:spPr>
+          <a:xfrm>
+            <a:off x="7869225" y="5662610"/>
+            <a:ext cx="828673" cy="371470"/>
+          </a:xfrm>
+          <a:prstGeom prst="rect">
+            <a:avLst/>
+          </a:prstGeom>
+          <a:solidFill>
+            <a:schemeClr val="bg1"/>
+          </a:solidFill>
+          <a:ln>
+            <a:solidFill>
+              <a:schemeClr val="bg1"/>
+            </a:solidFill>
+          </a:ln>
+        </p:spPr>
+        <p:style>
+          <a:lnRef idx="2">
+            <a:schemeClr val="accent6"/>
+          </a:lnRef>
+          <a:fillRef idx="1">
+            <a:schemeClr val="lt1"/>
+          </a:fillRef>
+          <a:effectRef idx="0">
+            <a:schemeClr val="accent6"/>
+          </a:effectRef>
+          <a:fontRef idx="minor">
+            <a:schemeClr val="dk1"/>
+          </a:fontRef>
+        </p:style>
+        <p:txBody>
+          <a:bodyPr rtlCol="0" anchor="ctr"/>
+          <a:lstStyle/>
+          <a:p>
+            <a:pPr algn="ctr"/>
+            <a:endParaRPr lang="en-US"/>
+          </a:p>
+        </p:txBody>
+      </p:sp>
+      <p:grpSp>
+        <p:nvGrpSpPr>
+          <p:cNvPr id="7" name="Group 6">
+            <a:extLst>
+              <a:ext uri="{FF2B5EF4-FFF2-40B4-BE49-F238E27FC236}">
+                <a16:creationId xmlns:a16="http://schemas.microsoft.com/office/drawing/2014/main" id="{5364C0EC-77C3-CCF7-EB8C-8F48F796F691}"/>
+              </a:ext>
+            </a:extLst>
+          </p:cNvPr>
+          <p:cNvGrpSpPr/>
+          <p:nvPr/>
+        </p:nvGrpSpPr>
+        <p:grpSpPr>
+          <a:xfrm>
+            <a:off x="3631468" y="714102"/>
+            <a:ext cx="1629820" cy="719871"/>
+            <a:chOff x="3762103" y="740229"/>
+            <a:chExt cx="1629820" cy="719871"/>
+          </a:xfrm>
+        </p:grpSpPr>
+        <p:sp>
+          <p:nvSpPr>
+            <p:cNvPr id="4" name="Rectangle 3">
+              <a:extLst>
+                <a:ext uri="{FF2B5EF4-FFF2-40B4-BE49-F238E27FC236}">
+                  <a16:creationId xmlns:a16="http://schemas.microsoft.com/office/drawing/2014/main" id="{CDD443C6-A6DC-3D52-992A-869FC58F215F}"/>
+                </a:ext>
+              </a:extLst>
+            </p:cNvPr>
+            <p:cNvSpPr/>
+            <p:nvPr/>
+          </p:nvSpPr>
+          <p:spPr>
+            <a:xfrm>
+              <a:off x="3781153" y="740229"/>
+              <a:ext cx="1610770" cy="719871"/>
+            </a:xfrm>
+            <a:prstGeom prst="rect">
+              <a:avLst/>
+            </a:prstGeom>
+            <a:solidFill>
+              <a:schemeClr val="bg1"/>
+            </a:solidFill>
+            <a:ln w="9525"/>
+          </p:spPr>
+          <p:style>
+            <a:lnRef idx="2">
+              <a:schemeClr val="accent1">
+                <a:shade val="15000"/>
+              </a:schemeClr>
+            </a:lnRef>
+            <a:fillRef idx="1">
+              <a:schemeClr val="accent1"/>
+            </a:fillRef>
+            <a:effectRef idx="0">
+              <a:schemeClr val="accent1"/>
+            </a:effectRef>
+            <a:fontRef idx="minor">
+              <a:schemeClr val="lt1"/>
+            </a:fontRef>
+          </p:style>
+          <p:txBody>
+            <a:bodyPr rtlCol="0" anchor="ctr"/>
+            <a:lstStyle/>
+            <a:p>
+              <a:pPr algn="ctr"/>
+              <a:endParaRPr lang="en-US"/>
+            </a:p>
+          </p:txBody>
+        </p:sp>
+        <p:pic>
+          <p:nvPicPr>
+            <p:cNvPr id="2" name="Picture 1">
+              <a:extLst>
+                <a:ext uri="{FF2B5EF4-FFF2-40B4-BE49-F238E27FC236}">
+                  <a16:creationId xmlns:a16="http://schemas.microsoft.com/office/drawing/2014/main" id="{7D67ADA9-5EBC-589C-D651-4FCAD126AA29}"/>
+                </a:ext>
+              </a:extLst>
+            </p:cNvPr>
+            <p:cNvPicPr>
+              <a:picLocks noChangeAspect="1"/>
+            </p:cNvPicPr>
+            <p:nvPr/>
+          </p:nvPicPr>
+          <p:blipFill>
+            <a:blip r:embed="rId3"/>
+            <a:srcRect l="13765" t="30810" r="7541" b="37142"/>
+            <a:stretch>
+              <a:fillRect/>
+            </a:stretch>
+          </p:blipFill>
+          <p:spPr>
+            <a:xfrm>
+              <a:off x="3762103" y="825137"/>
+              <a:ext cx="1610771" cy="596100"/>
+            </a:xfrm>
+            <a:prstGeom prst="rect">
+              <a:avLst/>
+            </a:prstGeom>
+          </p:spPr>
+        </p:pic>
+      </p:grpSp>
       <p:pic>
         <p:nvPicPr>
-          <p:cNvPr id="22" name="Picture 21">
-            <a:extLst>
-              <a:ext uri="{FF2B5EF4-FFF2-40B4-BE49-F238E27FC236}">
-                <a16:creationId xmlns:a16="http://schemas.microsoft.com/office/drawing/2014/main" id="{CAB3B78F-717D-9F3A-650C-302735D40BE3}"/>
+          <p:cNvPr id="16" name="Picture 15">
+            <a:extLst>
+              <a:ext uri="{FF2B5EF4-FFF2-40B4-BE49-F238E27FC236}">
+                <a16:creationId xmlns:a16="http://schemas.microsoft.com/office/drawing/2014/main" id="{7B6644C9-2EA0-3D8C-2C86-3FC4BEE70AFD}"/>
               </a:ext>
             </a:extLst>
           </p:cNvPr>
@@ -3380,22 +3673,22 @@
           <p:nvPr/>
         </p:nvPicPr>
         <p:blipFill>
-          <a:blip r:embed="rId2">
+          <a:blip r:embed="rId4">
             <a:extLst>
               <a:ext uri="{28A0092B-C50C-407E-A947-70E740481C1C}">
                 <a14:useLocalDpi xmlns:a14="http://schemas.microsoft.com/office/drawing/2010/main" val="0"/>
               </a:ext>
             </a:extLst>
           </a:blip>
-          <a:srcRect l="2676" r="67627"/>
+          <a:srcRect l="32165" t="21692" r="32165" b="22600"/>
           <a:stretch>
             <a:fillRect/>
           </a:stretch>
         </p:blipFill>
         <p:spPr>
           <a:xfrm>
-            <a:off x="4429579" y="1398983"/>
-            <a:ext cx="3508980" cy="3938838"/>
+            <a:off x="7858125" y="1080399"/>
+            <a:ext cx="1921979" cy="2235033"/>
           </a:xfrm>
           <a:prstGeom prst="rect">
             <a:avLst/>
@@ -3404,10 +3697,10 @@
       </p:pic>
       <p:pic>
         <p:nvPicPr>
-          <p:cNvPr id="10" name="Picture 9">
-            <a:extLst>
-              <a:ext uri="{FF2B5EF4-FFF2-40B4-BE49-F238E27FC236}">
-                <a16:creationId xmlns:a16="http://schemas.microsoft.com/office/drawing/2014/main" id="{B915C65E-FCA2-5689-71B8-FFB6B54C22F2}"/>
+          <p:cNvPr id="36" name="Picture 35">
+            <a:extLst>
+              <a:ext uri="{FF2B5EF4-FFF2-40B4-BE49-F238E27FC236}">
+                <a16:creationId xmlns:a16="http://schemas.microsoft.com/office/drawing/2014/main" id="{A635074B-6948-CAB7-019F-2730E70FFDE4}"/>
               </a:ext>
             </a:extLst>
           </p:cNvPr>
@@ -3417,71 +3710,34 @@
           <p:nvPr/>
         </p:nvPicPr>
         <p:blipFill>
-          <a:blip r:embed="rId2">
+          <a:blip r:embed="rId5">
             <a:extLst>
               <a:ext uri="{28A0092B-C50C-407E-A947-70E740481C1C}">
                 <a14:useLocalDpi xmlns:a14="http://schemas.microsoft.com/office/drawing/2010/main" val="0"/>
               </a:ext>
             </a:extLst>
           </a:blip>
-          <a:srcRect l="69374" r="-3492"/>
+          <a:srcRect l="38141" t="42785" r="38264" b="43174"/>
           <a:stretch>
             <a:fillRect/>
           </a:stretch>
         </p:blipFill>
         <p:spPr>
           <a:xfrm>
-            <a:off x="510175" y="1398984"/>
-            <a:ext cx="4031501" cy="3938838"/>
+            <a:off x="7894594" y="3239598"/>
+            <a:ext cx="1339538" cy="593546"/>
           </a:xfrm>
           <a:prstGeom prst="rect">
             <a:avLst/>
           </a:prstGeom>
         </p:spPr>
       </p:pic>
-      <p:pic>
-        <p:nvPicPr>
-          <p:cNvPr id="3" name="Picture 2">
-            <a:extLst>
-              <a:ext uri="{FF2B5EF4-FFF2-40B4-BE49-F238E27FC236}">
-                <a16:creationId xmlns:a16="http://schemas.microsoft.com/office/drawing/2014/main" id="{19FC5159-39B3-15DB-D255-04AEF7AD3153}"/>
-              </a:ext>
-            </a:extLst>
-          </p:cNvPr>
-          <p:cNvPicPr>
-            <a:picLocks noChangeAspect="1"/>
-          </p:cNvPicPr>
-          <p:nvPr/>
-        </p:nvPicPr>
-        <p:blipFill>
-          <a:blip r:embed="rId2">
-            <a:extLst>
-              <a:ext uri="{28A0092B-C50C-407E-A947-70E740481C1C}">
-                <a14:useLocalDpi xmlns:a14="http://schemas.microsoft.com/office/drawing/2010/main" val="0"/>
-              </a:ext>
-            </a:extLst>
-          </a:blip>
-          <a:srcRect l="36035" r="31981"/>
-          <a:stretch>
-            <a:fillRect/>
-          </a:stretch>
-        </p:blipFill>
-        <p:spPr>
-          <a:xfrm>
-            <a:off x="8369224" y="1398983"/>
-            <a:ext cx="3779400" cy="3938838"/>
-          </a:xfrm>
-          <a:prstGeom prst="rect">
-            <a:avLst/>
-          </a:prstGeom>
-        </p:spPr>
-      </p:pic>
-      <p:sp>
-        <p:nvSpPr>
-          <p:cNvPr id="7" name="Rectangle 6">
-            <a:extLst>
-              <a:ext uri="{FF2B5EF4-FFF2-40B4-BE49-F238E27FC236}">
-                <a16:creationId xmlns:a16="http://schemas.microsoft.com/office/drawing/2014/main" id="{99B6EF99-B3B3-576D-591A-B44B58CB55EE}"/>
+      <p:sp>
+        <p:nvSpPr>
+          <p:cNvPr id="8" name="Rectangle 7">
+            <a:extLst>
+              <a:ext uri="{FF2B5EF4-FFF2-40B4-BE49-F238E27FC236}">
+                <a16:creationId xmlns:a16="http://schemas.microsoft.com/office/drawing/2014/main" id="{C99E4CA3-DFCB-6C7F-031E-CC6DE8A3953F}"/>
               </a:ext>
             </a:extLst>
           </p:cNvPr>
@@ -3490,8 +3746,8 @@
         </p:nvSpPr>
         <p:spPr>
           <a:xfrm>
-            <a:off x="185486" y="1792705"/>
-            <a:ext cx="311819" cy="2995863"/>
+            <a:off x="8177142" y="3542569"/>
+            <a:ext cx="927432" cy="160841"/>
           </a:xfrm>
           <a:prstGeom prst="rect">
             <a:avLst/>
@@ -3532,10 +3788,10 @@
       </p:sp>
       <p:pic>
         <p:nvPicPr>
-          <p:cNvPr id="6" name="Picture 5">
-            <a:extLst>
-              <a:ext uri="{FF2B5EF4-FFF2-40B4-BE49-F238E27FC236}">
-                <a16:creationId xmlns:a16="http://schemas.microsoft.com/office/drawing/2014/main" id="{6FE39875-2E3C-E455-7C9C-5D08E7B38C49}"/>
+          <p:cNvPr id="12" name="Picture 11">
+            <a:extLst>
+              <a:ext uri="{FF2B5EF4-FFF2-40B4-BE49-F238E27FC236}">
+                <a16:creationId xmlns:a16="http://schemas.microsoft.com/office/drawing/2014/main" id="{3537951B-5B9C-00A0-ADF5-83C88B2918EA}"/>
               </a:ext>
             </a:extLst>
           </p:cNvPr>
@@ -3545,39 +3801,69 @@
           <p:nvPr/>
         </p:nvPicPr>
         <p:blipFill>
-          <a:blip r:embed="rId2">
+          <a:blip r:embed="rId5">
             <a:extLst>
               <a:ext uri="{28A0092B-C50C-407E-A947-70E740481C1C}">
                 <a14:useLocalDpi xmlns:a14="http://schemas.microsoft.com/office/drawing/2010/main" val="0"/>
               </a:ext>
             </a:extLst>
           </a:blip>
-          <a:srcRect r="97361"/>
+          <a:srcRect l="46923" t="49614" r="41406" b="44886"/>
           <a:stretch>
             <a:fillRect/>
           </a:stretch>
         </p:blipFill>
         <p:spPr>
           <a:xfrm>
-            <a:off x="125830" y="1359569"/>
-            <a:ext cx="311819" cy="3938838"/>
+            <a:off x="8212341" y="3526667"/>
+            <a:ext cx="662540" cy="232519"/>
           </a:xfrm>
           <a:prstGeom prst="rect">
             <a:avLst/>
           </a:prstGeom>
         </p:spPr>
       </p:pic>
+    </p:spTree>
+    <p:extLst>
+      <p:ext uri="{BB962C8B-B14F-4D97-AF65-F5344CB8AC3E}">
+        <p14:creationId xmlns:p14="http://schemas.microsoft.com/office/powerpoint/2010/main" val="620723726"/>
+      </p:ext>
+    </p:extLst>
+  </p:cSld>
+  <p:clrMapOvr>
+    <a:masterClrMapping/>
+  </p:clrMapOvr>
+</p:sld>
+</file>
+
+<file path=ppt/slides/slide2.xml><?xml version="1.0" encoding="utf-8"?>
+<p:sld xmlns:a="http://schemas.openxmlformats.org/drawingml/2006/main" xmlns:r="http://schemas.openxmlformats.org/officeDocument/2006/relationships" xmlns:p="http://schemas.openxmlformats.org/presentationml/2006/main">
+  <p:cSld>
+    <p:spTree>
+      <p:nvGrpSpPr>
+        <p:cNvPr id="1" name=""/>
+        <p:cNvGrpSpPr/>
+        <p:nvPr/>
+      </p:nvGrpSpPr>
+      <p:grpSpPr>
+        <a:xfrm>
+          <a:off x="0" y="0"/>
+          <a:ext cx="0" cy="0"/>
+          <a:chOff x="0" y="0"/>
+          <a:chExt cx="0" cy="0"/>
+        </a:xfrm>
+      </p:grpSpPr>
       <p:pic>
         <p:nvPicPr>
-          <p:cNvPr id="11" name="Picture 10">
-            <a:extLst>
-              <a:ext uri="{FF2B5EF4-FFF2-40B4-BE49-F238E27FC236}">
-                <a16:creationId xmlns:a16="http://schemas.microsoft.com/office/drawing/2014/main" id="{93CA5E7D-88D2-0D4C-910B-070332234677}"/>
+          <p:cNvPr id="5" name="Picture 4">
+            <a:extLst>
+              <a:ext uri="{FF2B5EF4-FFF2-40B4-BE49-F238E27FC236}">
+                <a16:creationId xmlns:a16="http://schemas.microsoft.com/office/drawing/2014/main" id="{624C2831-F414-94BA-31E7-62CDCAFC71F5}"/>
               </a:ext>
             </a:extLst>
           </p:cNvPr>
           <p:cNvPicPr>
-            <a:picLocks noChangeAspect="1"/>
+            <a:picLocks noGrp="1" noRot="1" noChangeAspect="1" noMove="1" noResize="1" noEditPoints="1" noAdjustHandles="1" noChangeArrowheads="1" noChangeShapeType="1" noCrop="1"/>
           </p:cNvPicPr>
           <p:nvPr/>
         </p:nvPicPr>
@@ -3589,396 +3875,19 @@
               </a:ext>
             </a:extLst>
           </a:blip>
-          <a:srcRect l="33965" t="76722" r="30809" b="725"/>
-          <a:stretch>
-            <a:fillRect/>
-          </a:stretch>
+          <a:srcRect/>
+          <a:stretch/>
         </p:blipFill>
         <p:spPr>
           <a:xfrm>
-            <a:off x="4468997" y="5969669"/>
-            <a:ext cx="4162425" cy="888331"/>
+            <a:off x="169720" y="1398984"/>
+            <a:ext cx="11816514" cy="3938838"/>
           </a:xfrm>
           <a:prstGeom prst="rect">
             <a:avLst/>
           </a:prstGeom>
         </p:spPr>
       </p:pic>
-      <p:pic>
-        <p:nvPicPr>
-          <p:cNvPr id="15" name="Picture 14">
-            <a:extLst>
-              <a:ext uri="{FF2B5EF4-FFF2-40B4-BE49-F238E27FC236}">
-                <a16:creationId xmlns:a16="http://schemas.microsoft.com/office/drawing/2014/main" id="{06BC8448-7934-D504-ED85-3E54E07E26DB}"/>
-              </a:ext>
-            </a:extLst>
-          </p:cNvPr>
-          <p:cNvPicPr>
-            <a:picLocks noChangeAspect="1"/>
-          </p:cNvPicPr>
-          <p:nvPr/>
-        </p:nvPicPr>
-        <p:blipFill>
-          <a:blip r:embed="rId2">
-            <a:extLst>
-              <a:ext uri="{28A0092B-C50C-407E-A947-70E740481C1C}">
-                <a14:useLocalDpi xmlns:a14="http://schemas.microsoft.com/office/drawing/2010/main" val="0"/>
-              </a:ext>
-            </a:extLst>
-          </a:blip>
-          <a:srcRect t="77447" r="64775"/>
-          <a:stretch>
-            <a:fillRect/>
-          </a:stretch>
-        </p:blipFill>
-        <p:spPr>
-          <a:xfrm>
-            <a:off x="497305" y="5969668"/>
-            <a:ext cx="4162426" cy="888332"/>
-          </a:xfrm>
-          <a:prstGeom prst="rect">
-            <a:avLst/>
-          </a:prstGeom>
-        </p:spPr>
-      </p:pic>
-      <p:pic>
-        <p:nvPicPr>
-          <p:cNvPr id="8" name="Picture 7">
-            <a:extLst>
-              <a:ext uri="{FF2B5EF4-FFF2-40B4-BE49-F238E27FC236}">
-                <a16:creationId xmlns:a16="http://schemas.microsoft.com/office/drawing/2014/main" id="{69F32806-A789-D6FA-9691-75CED68EA4CF}"/>
-              </a:ext>
-            </a:extLst>
-          </p:cNvPr>
-          <p:cNvPicPr>
-            <a:picLocks noChangeAspect="1"/>
-          </p:cNvPicPr>
-          <p:nvPr/>
-        </p:nvPicPr>
-        <p:blipFill>
-          <a:blip r:embed="rId2">
-            <a:extLst>
-              <a:ext uri="{28A0092B-C50C-407E-A947-70E740481C1C}">
-                <a14:useLocalDpi xmlns:a14="http://schemas.microsoft.com/office/drawing/2010/main" val="0"/>
-              </a:ext>
-            </a:extLst>
-          </a:blip>
-          <a:srcRect l="9164" t="85949" r="87484" b="8858"/>
-          <a:stretch>
-            <a:fillRect/>
-          </a:stretch>
-        </p:blipFill>
-        <p:spPr>
-          <a:xfrm>
-            <a:off x="8886891" y="4796451"/>
-            <a:ext cx="396040" cy="204537"/>
-          </a:xfrm>
-          <a:prstGeom prst="rect">
-            <a:avLst/>
-          </a:prstGeom>
-        </p:spPr>
-      </p:pic>
-      <p:grpSp>
-        <p:nvGrpSpPr>
-          <p:cNvPr id="13" name="Group 12">
-            <a:extLst>
-              <a:ext uri="{FF2B5EF4-FFF2-40B4-BE49-F238E27FC236}">
-                <a16:creationId xmlns:a16="http://schemas.microsoft.com/office/drawing/2014/main" id="{F10A322D-B252-895D-CB90-FA8C6F47400F}"/>
-              </a:ext>
-            </a:extLst>
-          </p:cNvPr>
-          <p:cNvGrpSpPr/>
-          <p:nvPr/>
-        </p:nvGrpSpPr>
-        <p:grpSpPr>
-          <a:xfrm>
-            <a:off x="9207062" y="4791965"/>
-            <a:ext cx="553312" cy="204538"/>
-            <a:chOff x="5258551" y="4747643"/>
-            <a:chExt cx="553312" cy="204538"/>
-          </a:xfrm>
-        </p:grpSpPr>
-        <p:pic>
-          <p:nvPicPr>
-            <p:cNvPr id="12" name="Picture 11">
-              <a:extLst>
-                <a:ext uri="{FF2B5EF4-FFF2-40B4-BE49-F238E27FC236}">
-                  <a16:creationId xmlns:a16="http://schemas.microsoft.com/office/drawing/2014/main" id="{05F1279E-C360-E6EC-F883-49D81A95B085}"/>
-                </a:ext>
-              </a:extLst>
-            </p:cNvPr>
-            <p:cNvPicPr>
-              <a:picLocks noChangeAspect="1"/>
-            </p:cNvPicPr>
-            <p:nvPr/>
-          </p:nvPicPr>
-          <p:blipFill>
-            <a:blip r:embed="rId2">
-              <a:extLst>
-                <a:ext uri="{28A0092B-C50C-407E-A947-70E740481C1C}">
-                  <a14:useLocalDpi xmlns:a14="http://schemas.microsoft.com/office/drawing/2010/main" val="0"/>
-                </a:ext>
-              </a:extLst>
-            </a:blip>
-            <a:srcRect l="46761" t="86153" r="48967" b="9494"/>
-            <a:stretch>
-              <a:fillRect/>
-            </a:stretch>
-          </p:blipFill>
-          <p:spPr>
-            <a:xfrm>
-              <a:off x="5258551" y="4759679"/>
-              <a:ext cx="504825" cy="171450"/>
-            </a:xfrm>
-            <a:prstGeom prst="rect">
-              <a:avLst/>
-            </a:prstGeom>
-          </p:spPr>
-        </p:pic>
-        <p:pic>
-          <p:nvPicPr>
-            <p:cNvPr id="9" name="Picture 8">
-              <a:extLst>
-                <a:ext uri="{FF2B5EF4-FFF2-40B4-BE49-F238E27FC236}">
-                  <a16:creationId xmlns:a16="http://schemas.microsoft.com/office/drawing/2014/main" id="{F504C0A9-0AD8-BEF1-203F-797491ABA192}"/>
-                </a:ext>
-              </a:extLst>
-            </p:cNvPr>
-            <p:cNvPicPr>
-              <a:picLocks noChangeAspect="1"/>
-            </p:cNvPicPr>
-            <p:nvPr/>
-          </p:nvPicPr>
-          <p:blipFill>
-            <a:blip r:embed="rId2">
-              <a:extLst>
-                <a:ext uri="{28A0092B-C50C-407E-A947-70E740481C1C}">
-                  <a14:useLocalDpi xmlns:a14="http://schemas.microsoft.com/office/drawing/2010/main" val="0"/>
-                </a:ext>
-              </a:extLst>
-            </a:blip>
-            <a:srcRect l="59444" t="85936" r="38110" b="8871"/>
-            <a:stretch>
-              <a:fillRect/>
-            </a:stretch>
-          </p:blipFill>
-          <p:spPr>
-            <a:xfrm>
-              <a:off x="5522864" y="4747643"/>
-              <a:ext cx="288999" cy="204538"/>
-            </a:xfrm>
-            <a:prstGeom prst="rect">
-              <a:avLst/>
-            </a:prstGeom>
-          </p:spPr>
-        </p:pic>
-      </p:grpSp>
-      <p:pic>
-        <p:nvPicPr>
-          <p:cNvPr id="16" name="Picture 15">
-            <a:extLst>
-              <a:ext uri="{FF2B5EF4-FFF2-40B4-BE49-F238E27FC236}">
-                <a16:creationId xmlns:a16="http://schemas.microsoft.com/office/drawing/2014/main" id="{E3BE1C25-9604-516D-3F88-BBD600036B75}"/>
-              </a:ext>
-            </a:extLst>
-          </p:cNvPr>
-          <p:cNvPicPr>
-            <a:picLocks noChangeAspect="1"/>
-          </p:cNvPicPr>
-          <p:nvPr/>
-        </p:nvPicPr>
-        <p:blipFill>
-          <a:blip r:embed="rId2">
-            <a:extLst>
-              <a:ext uri="{28A0092B-C50C-407E-A947-70E740481C1C}">
-                <a14:useLocalDpi xmlns:a14="http://schemas.microsoft.com/office/drawing/2010/main" val="0"/>
-              </a:ext>
-            </a:extLst>
-          </a:blip>
-          <a:srcRect l="13169" t="86063" r="83718" b="9584"/>
-          <a:stretch>
-            <a:fillRect/>
-          </a:stretch>
-        </p:blipFill>
-        <p:spPr>
-          <a:xfrm>
-            <a:off x="9711887" y="4793369"/>
-            <a:ext cx="367905" cy="171451"/>
-          </a:xfrm>
-          <a:prstGeom prst="rect">
-            <a:avLst/>
-          </a:prstGeom>
-        </p:spPr>
-      </p:pic>
-      <p:pic>
-        <p:nvPicPr>
-          <p:cNvPr id="17" name="Picture 16">
-            <a:extLst>
-              <a:ext uri="{FF2B5EF4-FFF2-40B4-BE49-F238E27FC236}">
-                <a16:creationId xmlns:a16="http://schemas.microsoft.com/office/drawing/2014/main" id="{D08B67C6-6115-227A-F5E5-30D5EB4B7001}"/>
-              </a:ext>
-            </a:extLst>
-          </p:cNvPr>
-          <p:cNvPicPr>
-            <a:picLocks noChangeAspect="1"/>
-          </p:cNvPicPr>
-          <p:nvPr/>
-        </p:nvPicPr>
-        <p:blipFill>
-          <a:blip r:embed="rId2">
-            <a:extLst>
-              <a:ext uri="{28A0092B-C50C-407E-A947-70E740481C1C}">
-                <a14:useLocalDpi xmlns:a14="http://schemas.microsoft.com/office/drawing/2010/main" val="0"/>
-              </a:ext>
-            </a:extLst>
-          </a:blip>
-          <a:srcRect l="17612" t="86056" r="80050" b="9592"/>
-          <a:stretch>
-            <a:fillRect/>
-          </a:stretch>
-        </p:blipFill>
-        <p:spPr>
-          <a:xfrm>
-            <a:off x="10594506" y="4789976"/>
-            <a:ext cx="276266" cy="171450"/>
-          </a:xfrm>
-          <a:prstGeom prst="rect">
-            <a:avLst/>
-          </a:prstGeom>
-        </p:spPr>
-      </p:pic>
-      <p:grpSp>
-        <p:nvGrpSpPr>
-          <p:cNvPr id="20" name="Group 19">
-            <a:extLst>
-              <a:ext uri="{FF2B5EF4-FFF2-40B4-BE49-F238E27FC236}">
-                <a16:creationId xmlns:a16="http://schemas.microsoft.com/office/drawing/2014/main" id="{9C94A9BA-B484-AA01-FA53-E5B97B25E1D3}"/>
-              </a:ext>
-            </a:extLst>
-          </p:cNvPr>
-          <p:cNvGrpSpPr/>
-          <p:nvPr/>
-        </p:nvGrpSpPr>
-        <p:grpSpPr>
-          <a:xfrm>
-            <a:off x="10083036" y="4825604"/>
-            <a:ext cx="448248" cy="167535"/>
-            <a:chOff x="6162043" y="4769722"/>
-            <a:chExt cx="448248" cy="167535"/>
-          </a:xfrm>
-        </p:grpSpPr>
-        <p:pic>
-          <p:nvPicPr>
-            <p:cNvPr id="18" name="Picture 17">
-              <a:extLst>
-                <a:ext uri="{FF2B5EF4-FFF2-40B4-BE49-F238E27FC236}">
-                  <a16:creationId xmlns:a16="http://schemas.microsoft.com/office/drawing/2014/main" id="{A4027440-ACBF-8E04-4EF1-649A38777814}"/>
-                </a:ext>
-              </a:extLst>
-            </p:cNvPr>
-            <p:cNvPicPr>
-              <a:picLocks noChangeAspect="1"/>
-            </p:cNvPicPr>
-            <p:nvPr/>
-          </p:nvPicPr>
-          <p:blipFill>
-            <a:blip r:embed="rId2">
-              <a:extLst>
-                <a:ext uri="{28A0092B-C50C-407E-A947-70E740481C1C}">
-                  <a14:useLocalDpi xmlns:a14="http://schemas.microsoft.com/office/drawing/2010/main" val="0"/>
-                </a:ext>
-              </a:extLst>
-            </a:blip>
-            <a:srcRect l="57881" t="86519" r="38700" b="9228"/>
-            <a:stretch>
-              <a:fillRect/>
-            </a:stretch>
-          </p:blipFill>
-          <p:spPr>
-            <a:xfrm>
-              <a:off x="6206254" y="4769722"/>
-              <a:ext cx="404037" cy="167535"/>
-            </a:xfrm>
-            <a:prstGeom prst="rect">
-              <a:avLst/>
-            </a:prstGeom>
-          </p:spPr>
-        </p:pic>
-        <p:pic>
-          <p:nvPicPr>
-            <p:cNvPr id="19" name="Picture 18">
-              <a:extLst>
-                <a:ext uri="{FF2B5EF4-FFF2-40B4-BE49-F238E27FC236}">
-                  <a16:creationId xmlns:a16="http://schemas.microsoft.com/office/drawing/2014/main" id="{01704D53-E326-993B-C81D-9754EA8F44CC}"/>
-                </a:ext>
-              </a:extLst>
-            </p:cNvPr>
-            <p:cNvPicPr>
-              <a:picLocks noChangeAspect="1"/>
-            </p:cNvPicPr>
-            <p:nvPr/>
-          </p:nvPicPr>
-          <p:blipFill>
-            <a:blip r:embed="rId2">
-              <a:extLst>
-                <a:ext uri="{28A0092B-C50C-407E-A947-70E740481C1C}">
-                  <a14:useLocalDpi xmlns:a14="http://schemas.microsoft.com/office/drawing/2010/main" val="0"/>
-                </a:ext>
-              </a:extLst>
-            </a:blip>
-            <a:srcRect l="47219" t="86710" r="51863" b="10217"/>
-            <a:stretch>
-              <a:fillRect/>
-            </a:stretch>
-          </p:blipFill>
-          <p:spPr>
-            <a:xfrm>
-              <a:off x="6162043" y="4769723"/>
-              <a:ext cx="108399" cy="121091"/>
-            </a:xfrm>
-            <a:prstGeom prst="rect">
-              <a:avLst/>
-            </a:prstGeom>
-          </p:spPr>
-        </p:pic>
-      </p:grpSp>
-      <p:pic>
-        <p:nvPicPr>
-          <p:cNvPr id="21" name="Picture 20">
-            <a:extLst>
-              <a:ext uri="{FF2B5EF4-FFF2-40B4-BE49-F238E27FC236}">
-                <a16:creationId xmlns:a16="http://schemas.microsoft.com/office/drawing/2014/main" id="{C664961B-E9FA-3FBA-FB41-A2248F87C297}"/>
-              </a:ext>
-            </a:extLst>
-          </p:cNvPr>
-          <p:cNvPicPr>
-            <a:picLocks noChangeAspect="1"/>
-          </p:cNvPicPr>
-          <p:nvPr/>
-        </p:nvPicPr>
-        <p:blipFill>
-          <a:blip r:embed="rId2">
-            <a:extLst>
-              <a:ext uri="{28A0092B-C50C-407E-A947-70E740481C1C}">
-                <a14:useLocalDpi xmlns:a14="http://schemas.microsoft.com/office/drawing/2010/main" val="0"/>
-              </a:ext>
-            </a:extLst>
-          </a:blip>
-          <a:srcRect l="20632" t="86428" r="74514" b="8708"/>
-          <a:stretch>
-            <a:fillRect/>
-          </a:stretch>
-        </p:blipFill>
-        <p:spPr>
-          <a:xfrm>
-            <a:off x="11287110" y="4801130"/>
-            <a:ext cx="573601" cy="191589"/>
-          </a:xfrm>
-          <a:prstGeom prst="rect">
-            <a:avLst/>
-          </a:prstGeom>
-        </p:spPr>
-      </p:pic>
       <p:sp>
         <p:nvSpPr>
           <p:cNvPr id="26" name="TextBox 25">
@@ -3988,7 +3897,9 @@
               </a:ext>
             </a:extLst>
           </p:cNvPr>
-          <p:cNvSpPr txBox="1"/>
+          <p:cNvSpPr txBox="1">
+            <a:spLocks noGrp="1" noRot="1" noMove="1" noResize="1" noEditPoints="1" noAdjustHandles="1" noChangeArrowheads="1" noChangeShapeType="1"/>
+          </p:cNvSpPr>
           <p:nvPr/>
         </p:nvSpPr>
         <p:spPr>
@@ -4023,7 +3934,9 @@
               </a:ext>
             </a:extLst>
           </p:cNvPr>
-          <p:cNvSpPr txBox="1"/>
+          <p:cNvSpPr txBox="1">
+            <a:spLocks noGrp="1" noRot="1" noMove="1" noResize="1" noEditPoints="1" noAdjustHandles="1" noChangeArrowheads="1" noChangeShapeType="1"/>
+          </p:cNvSpPr>
           <p:nvPr/>
         </p:nvSpPr>
         <p:spPr>
@@ -4058,7 +3971,9 @@
               </a:ext>
             </a:extLst>
           </p:cNvPr>
-          <p:cNvSpPr txBox="1"/>
+          <p:cNvSpPr txBox="1">
+            <a:spLocks noGrp="1" noRot="1" noMove="1" noResize="1" noEditPoints="1" noAdjustHandles="1" noChangeArrowheads="1" noChangeShapeType="1"/>
+          </p:cNvSpPr>
           <p:nvPr/>
         </p:nvSpPr>
         <p:spPr>
@@ -4084,134 +3999,6 @@
           </a:p>
         </p:txBody>
       </p:sp>
-      <p:grpSp>
-        <p:nvGrpSpPr>
-          <p:cNvPr id="24" name="Group 23">
-            <a:extLst>
-              <a:ext uri="{FF2B5EF4-FFF2-40B4-BE49-F238E27FC236}">
-                <a16:creationId xmlns:a16="http://schemas.microsoft.com/office/drawing/2014/main" id="{5354B883-4B13-D289-ADD1-032391EA0A5B}"/>
-              </a:ext>
-            </a:extLst>
-          </p:cNvPr>
-          <p:cNvGrpSpPr/>
-          <p:nvPr/>
-        </p:nvGrpSpPr>
-        <p:grpSpPr>
-          <a:xfrm>
-            <a:off x="1032696" y="4264348"/>
-            <a:ext cx="1828800" cy="358072"/>
-            <a:chOff x="8843624" y="4201286"/>
-            <a:chExt cx="1828800" cy="358072"/>
-          </a:xfrm>
-        </p:grpSpPr>
-        <p:pic>
-          <p:nvPicPr>
-            <p:cNvPr id="30" name="Picture 29">
-              <a:extLst>
-                <a:ext uri="{FF2B5EF4-FFF2-40B4-BE49-F238E27FC236}">
-                  <a16:creationId xmlns:a16="http://schemas.microsoft.com/office/drawing/2014/main" id="{53966B41-D9ED-6764-BB2D-8847DF7475EF}"/>
-                </a:ext>
-              </a:extLst>
-            </p:cNvPr>
-            <p:cNvPicPr>
-              <a:picLocks noChangeAspect="1"/>
-            </p:cNvPicPr>
-            <p:nvPr/>
-          </p:nvPicPr>
-          <p:blipFill>
-            <a:blip r:embed="rId3"/>
-            <a:srcRect l="6805" r="38517"/>
-            <a:stretch>
-              <a:fillRect/>
-            </a:stretch>
-          </p:blipFill>
-          <p:spPr>
-            <a:xfrm rot="16200000">
-              <a:off x="9538696" y="3893923"/>
-              <a:ext cx="170494" cy="1160376"/>
-            </a:xfrm>
-            <a:prstGeom prst="rect">
-              <a:avLst/>
-            </a:prstGeom>
-          </p:spPr>
-        </p:pic>
-        <p:sp>
-          <p:nvSpPr>
-            <p:cNvPr id="37" name="TextBox 36">
-              <a:extLst>
-                <a:ext uri="{FF2B5EF4-FFF2-40B4-BE49-F238E27FC236}">
-                  <a16:creationId xmlns:a16="http://schemas.microsoft.com/office/drawing/2014/main" id="{E34A391B-16C4-3D8E-B38A-AC53C8B78F3B}"/>
-                </a:ext>
-              </a:extLst>
-            </p:cNvPr>
-            <p:cNvSpPr txBox="1"/>
-            <p:nvPr/>
-          </p:nvSpPr>
-          <p:spPr>
-            <a:xfrm>
-              <a:off x="9758024" y="4201286"/>
-              <a:ext cx="914400" cy="215444"/>
-            </a:xfrm>
-            <a:prstGeom prst="rect">
-              <a:avLst/>
-            </a:prstGeom>
-            <a:noFill/>
-          </p:spPr>
-          <p:txBody>
-            <a:bodyPr wrap="square" rtlCol="0">
-              <a:spAutoFit/>
-            </a:bodyPr>
-            <a:lstStyle/>
-            <a:p>
-              <a:r>
-                <a:rPr lang="en-US" sz="800" dirty="0">
-                  <a:latin typeface="Helvetica" panose="020B0604020202020204" pitchFamily="34" charset="0"/>
-                  <a:cs typeface="Helvetica" panose="020B0604020202020204" pitchFamily="34" charset="0"/>
-                </a:rPr>
-                <a:t>NC warmer</a:t>
-              </a:r>
-            </a:p>
-          </p:txBody>
-        </p:sp>
-        <p:sp>
-          <p:nvSpPr>
-            <p:cNvPr id="38" name="TextBox 37">
-              <a:extLst>
-                <a:ext uri="{FF2B5EF4-FFF2-40B4-BE49-F238E27FC236}">
-                  <a16:creationId xmlns:a16="http://schemas.microsoft.com/office/drawing/2014/main" id="{23105D28-3712-BDD1-C547-D0980DBCA1D8}"/>
-                </a:ext>
-              </a:extLst>
-            </p:cNvPr>
-            <p:cNvSpPr txBox="1"/>
-            <p:nvPr/>
-          </p:nvSpPr>
-          <p:spPr>
-            <a:xfrm>
-              <a:off x="8843624" y="4201286"/>
-              <a:ext cx="914400" cy="215444"/>
-            </a:xfrm>
-            <a:prstGeom prst="rect">
-              <a:avLst/>
-            </a:prstGeom>
-            <a:noFill/>
-          </p:spPr>
-          <p:txBody>
-            <a:bodyPr wrap="square" rtlCol="0">
-              <a:spAutoFit/>
-            </a:bodyPr>
-            <a:lstStyle/>
-            <a:p>
-              <a:r>
-                <a:rPr lang="en-US" sz="800" dirty="0">
-                  <a:latin typeface="Helvetica" panose="020B0604020202020204" pitchFamily="34" charset="0"/>
-                  <a:cs typeface="Helvetica" panose="020B0604020202020204" pitchFamily="34" charset="0"/>
-                </a:rPr>
-                <a:t>NC colder</a:t>
-              </a:r>
-            </a:p>
-          </p:txBody>
-        </p:sp>
-      </p:grpSp>
       <p:sp>
         <p:nvSpPr>
           <p:cNvPr id="23" name="Rectangle 22">
@@ -4266,6 +4053,402 @@
           </a:p>
         </p:txBody>
       </p:sp>
+      <p:pic>
+        <p:nvPicPr>
+          <p:cNvPr id="51" name="Graphic 50" descr="Caterpillar with solid fill">
+            <a:extLst>
+              <a:ext uri="{FF2B5EF4-FFF2-40B4-BE49-F238E27FC236}">
+                <a16:creationId xmlns:a16="http://schemas.microsoft.com/office/drawing/2014/main" id="{5F810E77-A180-FCA6-24FA-E06899288DE2}"/>
+              </a:ext>
+            </a:extLst>
+          </p:cNvPr>
+          <p:cNvPicPr>
+            <a:picLocks noChangeAspect="1"/>
+          </p:cNvPicPr>
+          <p:nvPr/>
+        </p:nvPicPr>
+        <p:blipFill>
+          <a:blip>
+            <a:extLst>
+              <a:ext uri="{96DAC541-7B7A-43D3-8B79-37D633B846F1}">
+                <asvg:svgBlip xmlns:asvg="http://schemas.microsoft.com/office/drawing/2016/SVG/main" r:embed="rId3"/>
+              </a:ext>
+            </a:extLst>
+          </a:blip>
+          <a:stretch>
+            <a:fillRect/>
+          </a:stretch>
+        </p:blipFill>
+        <p:spPr>
+          <a:xfrm>
+            <a:off x="11261680" y="4165123"/>
+            <a:ext cx="547638" cy="547638"/>
+          </a:xfrm>
+          <a:prstGeom prst="rect">
+            <a:avLst/>
+          </a:prstGeom>
+        </p:spPr>
+      </p:pic>
+      <p:pic>
+        <p:nvPicPr>
+          <p:cNvPr id="52" name="Graphic 51" descr="Blueberry with solid fill">
+            <a:extLst>
+              <a:ext uri="{FF2B5EF4-FFF2-40B4-BE49-F238E27FC236}">
+                <a16:creationId xmlns:a16="http://schemas.microsoft.com/office/drawing/2014/main" id="{94585A14-016C-ED73-B126-D0EC3E92DC30}"/>
+              </a:ext>
+            </a:extLst>
+          </p:cNvPr>
+          <p:cNvPicPr>
+            <a:picLocks noChangeAspect="1"/>
+          </p:cNvPicPr>
+          <p:nvPr/>
+        </p:nvPicPr>
+        <p:blipFill>
+          <a:blip>
+            <a:extLst>
+              <a:ext uri="{96DAC541-7B7A-43D3-8B79-37D633B846F1}">
+                <asvg:svgBlip xmlns:asvg="http://schemas.microsoft.com/office/drawing/2016/SVG/main" r:embed="rId4"/>
+              </a:ext>
+            </a:extLst>
+          </a:blip>
+          <a:stretch>
+            <a:fillRect/>
+          </a:stretch>
+        </p:blipFill>
+        <p:spPr>
+          <a:xfrm>
+            <a:off x="8798458" y="4223572"/>
+            <a:ext cx="477672" cy="477672"/>
+          </a:xfrm>
+          <a:prstGeom prst="rect">
+            <a:avLst/>
+          </a:prstGeom>
+        </p:spPr>
+      </p:pic>
+      <p:pic>
+        <p:nvPicPr>
+          <p:cNvPr id="53" name="Graphic 52" descr="Thermometer with solid fill">
+            <a:extLst>
+              <a:ext uri="{FF2B5EF4-FFF2-40B4-BE49-F238E27FC236}">
+                <a16:creationId xmlns:a16="http://schemas.microsoft.com/office/drawing/2014/main" id="{FC7ADC1C-7C9F-1BA8-830F-77FD209EF849}"/>
+              </a:ext>
+            </a:extLst>
+          </p:cNvPr>
+          <p:cNvPicPr>
+            <a:picLocks noChangeAspect="1"/>
+          </p:cNvPicPr>
+          <p:nvPr/>
+        </p:nvPicPr>
+        <p:blipFill>
+          <a:blip>
+            <a:extLst>
+              <a:ext uri="{96DAC541-7B7A-43D3-8B79-37D633B846F1}">
+                <asvg:svgBlip xmlns:asvg="http://schemas.microsoft.com/office/drawing/2016/SVG/main" r:embed="rId5"/>
+              </a:ext>
+            </a:extLst>
+          </a:blip>
+          <a:stretch>
+            <a:fillRect/>
+          </a:stretch>
+        </p:blipFill>
+        <p:spPr>
+          <a:xfrm>
+            <a:off x="930320" y="4164817"/>
+            <a:ext cx="461665" cy="461665"/>
+          </a:xfrm>
+          <a:prstGeom prst="rect">
+            <a:avLst/>
+          </a:prstGeom>
+        </p:spPr>
+      </p:pic>
+      <p:pic>
+        <p:nvPicPr>
+          <p:cNvPr id="54" name="Graphic 53" descr="Thermometer with solid fill">
+            <a:extLst>
+              <a:ext uri="{FF2B5EF4-FFF2-40B4-BE49-F238E27FC236}">
+                <a16:creationId xmlns:a16="http://schemas.microsoft.com/office/drawing/2014/main" id="{D0FB7E86-5ED5-2B90-2E5C-3D8F1C00D49A}"/>
+              </a:ext>
+            </a:extLst>
+          </p:cNvPr>
+          <p:cNvPicPr>
+            <a:picLocks noChangeAspect="1"/>
+          </p:cNvPicPr>
+          <p:nvPr/>
+        </p:nvPicPr>
+        <p:blipFill>
+          <a:blip>
+            <a:extLst>
+              <a:ext uri="{96DAC541-7B7A-43D3-8B79-37D633B846F1}">
+                <asvg:svgBlip xmlns:asvg="http://schemas.microsoft.com/office/drawing/2016/SVG/main" r:embed="rId5"/>
+              </a:ext>
+            </a:extLst>
+          </a:blip>
+          <a:stretch>
+            <a:fillRect/>
+          </a:stretch>
+        </p:blipFill>
+        <p:spPr>
+          <a:xfrm>
+            <a:off x="3296370" y="4187422"/>
+            <a:ext cx="461665" cy="461665"/>
+          </a:xfrm>
+          <a:prstGeom prst="rect">
+            <a:avLst/>
+          </a:prstGeom>
+        </p:spPr>
+      </p:pic>
+      <p:pic>
+        <p:nvPicPr>
+          <p:cNvPr id="55" name="Graphic 54" descr="Snowflake with solid fill">
+            <a:extLst>
+              <a:ext uri="{FF2B5EF4-FFF2-40B4-BE49-F238E27FC236}">
+                <a16:creationId xmlns:a16="http://schemas.microsoft.com/office/drawing/2014/main" id="{3B7CFB50-5BAF-E551-3CE7-43EA9A20AEB8}"/>
+              </a:ext>
+            </a:extLst>
+          </p:cNvPr>
+          <p:cNvPicPr>
+            <a:picLocks noChangeAspect="1"/>
+          </p:cNvPicPr>
+          <p:nvPr/>
+        </p:nvPicPr>
+        <p:blipFill>
+          <a:blip>
+            <a:extLst>
+              <a:ext uri="{96DAC541-7B7A-43D3-8B79-37D633B846F1}">
+                <asvg:svgBlip xmlns:asvg="http://schemas.microsoft.com/office/drawing/2016/SVG/main" r:embed="rId6"/>
+              </a:ext>
+            </a:extLst>
+          </a:blip>
+          <a:stretch>
+            <a:fillRect/>
+          </a:stretch>
+        </p:blipFill>
+        <p:spPr>
+          <a:xfrm>
+            <a:off x="1156555" y="4027490"/>
+            <a:ext cx="518987" cy="518987"/>
+          </a:xfrm>
+          <a:prstGeom prst="rect">
+            <a:avLst/>
+          </a:prstGeom>
+        </p:spPr>
+      </p:pic>
+      <p:pic>
+        <p:nvPicPr>
+          <p:cNvPr id="56" name="Graphic 55" descr="Fire with solid fill">
+            <a:extLst>
+              <a:ext uri="{FF2B5EF4-FFF2-40B4-BE49-F238E27FC236}">
+                <a16:creationId xmlns:a16="http://schemas.microsoft.com/office/drawing/2014/main" id="{92E22670-EA35-109B-9DB3-CD27B0D0591D}"/>
+              </a:ext>
+            </a:extLst>
+          </p:cNvPr>
+          <p:cNvPicPr>
+            <a:picLocks noChangeAspect="1"/>
+          </p:cNvPicPr>
+          <p:nvPr/>
+        </p:nvPicPr>
+        <p:blipFill>
+          <a:blip>
+            <a:extLst>
+              <a:ext uri="{96DAC541-7B7A-43D3-8B79-37D633B846F1}">
+                <asvg:svgBlip xmlns:asvg="http://schemas.microsoft.com/office/drawing/2016/SVG/main" r:embed="rId7"/>
+              </a:ext>
+            </a:extLst>
+          </a:blip>
+          <a:stretch>
+            <a:fillRect/>
+          </a:stretch>
+        </p:blipFill>
+        <p:spPr>
+          <a:xfrm>
+            <a:off x="3527203" y="4003428"/>
+            <a:ext cx="461665" cy="461665"/>
+          </a:xfrm>
+          <a:prstGeom prst="rect">
+            <a:avLst/>
+          </a:prstGeom>
+        </p:spPr>
+      </p:pic>
+      <p:pic>
+        <p:nvPicPr>
+          <p:cNvPr id="57" name="Graphic 56" descr="Forest scene with solid fill">
+            <a:extLst>
+              <a:ext uri="{FF2B5EF4-FFF2-40B4-BE49-F238E27FC236}">
+                <a16:creationId xmlns:a16="http://schemas.microsoft.com/office/drawing/2014/main" id="{816F0776-BB44-38F3-DA2D-7FCAFDC7E8C1}"/>
+              </a:ext>
+            </a:extLst>
+          </p:cNvPr>
+          <p:cNvPicPr>
+            <a:picLocks noChangeAspect="1"/>
+          </p:cNvPicPr>
+          <p:nvPr/>
+        </p:nvPicPr>
+        <p:blipFill>
+          <a:blip>
+            <a:extLst>
+              <a:ext uri="{96DAC541-7B7A-43D3-8B79-37D633B846F1}">
+                <asvg:svgBlip xmlns:asvg="http://schemas.microsoft.com/office/drawing/2016/SVG/main" r:embed="rId8"/>
+              </a:ext>
+            </a:extLst>
+          </a:blip>
+          <a:stretch>
+            <a:fillRect/>
+          </a:stretch>
+        </p:blipFill>
+        <p:spPr>
+          <a:xfrm>
+            <a:off x="7216505" y="3998828"/>
+            <a:ext cx="692975" cy="692975"/>
+          </a:xfrm>
+          <a:prstGeom prst="rect">
+            <a:avLst/>
+          </a:prstGeom>
+        </p:spPr>
+      </p:pic>
+      <p:pic>
+        <p:nvPicPr>
+          <p:cNvPr id="58" name="Graphic 57" descr="Forest scene with solid fill">
+            <a:extLst>
+              <a:ext uri="{FF2B5EF4-FFF2-40B4-BE49-F238E27FC236}">
+                <a16:creationId xmlns:a16="http://schemas.microsoft.com/office/drawing/2014/main" id="{4FD0F885-10E6-494E-3EFB-BBF7F554F02F}"/>
+              </a:ext>
+            </a:extLst>
+          </p:cNvPr>
+          <p:cNvPicPr>
+            <a:picLocks noChangeAspect="1"/>
+          </p:cNvPicPr>
+          <p:nvPr/>
+        </p:nvPicPr>
+        <p:blipFill>
+          <a:blip>
+            <a:extLst>
+              <a:ext uri="{96DAC541-7B7A-43D3-8B79-37D633B846F1}">
+                <asvg:svgBlip xmlns:asvg="http://schemas.microsoft.com/office/drawing/2016/SVG/main" r:embed="rId8"/>
+              </a:ext>
+            </a:extLst>
+          </a:blip>
+          <a:stretch>
+            <a:fillRect/>
+          </a:stretch>
+        </p:blipFill>
+        <p:spPr>
+          <a:xfrm>
+            <a:off x="4934844" y="4337050"/>
+            <a:ext cx="345643" cy="345643"/>
+          </a:xfrm>
+          <a:prstGeom prst="rect">
+            <a:avLst/>
+          </a:prstGeom>
+        </p:spPr>
+      </p:pic>
+      <p:pic>
+        <p:nvPicPr>
+          <p:cNvPr id="59" name="Graphic 58" descr="Crops with solid fill">
+            <a:extLst>
+              <a:ext uri="{FF2B5EF4-FFF2-40B4-BE49-F238E27FC236}">
+                <a16:creationId xmlns:a16="http://schemas.microsoft.com/office/drawing/2014/main" id="{C3E0F115-6874-8A59-8AEB-75D67AD912A1}"/>
+              </a:ext>
+            </a:extLst>
+          </p:cNvPr>
+          <p:cNvPicPr>
+            <a:picLocks noChangeAspect="1"/>
+          </p:cNvPicPr>
+          <p:nvPr/>
+        </p:nvPicPr>
+        <p:blipFill>
+          <a:blip>
+            <a:extLst>
+              <a:ext uri="{96DAC541-7B7A-43D3-8B79-37D633B846F1}">
+                <asvg:svgBlip xmlns:asvg="http://schemas.microsoft.com/office/drawing/2016/SVG/main" r:embed="rId9"/>
+              </a:ext>
+            </a:extLst>
+          </a:blip>
+          <a:stretch>
+            <a:fillRect/>
+          </a:stretch>
+        </p:blipFill>
+        <p:spPr>
+          <a:xfrm>
+            <a:off x="5255252" y="4330700"/>
+            <a:ext cx="347468" cy="347468"/>
+          </a:xfrm>
+          <a:prstGeom prst="rect">
+            <a:avLst/>
+          </a:prstGeom>
+        </p:spPr>
+      </p:pic>
+      <p:pic>
+        <p:nvPicPr>
+          <p:cNvPr id="60" name="Graphic 59" descr="City with solid fill">
+            <a:extLst>
+              <a:ext uri="{FF2B5EF4-FFF2-40B4-BE49-F238E27FC236}">
+                <a16:creationId xmlns:a16="http://schemas.microsoft.com/office/drawing/2014/main" id="{39111131-77EA-7B32-46E2-6CAFE190A3EE}"/>
+              </a:ext>
+            </a:extLst>
+          </p:cNvPr>
+          <p:cNvPicPr>
+            <a:picLocks noChangeAspect="1"/>
+          </p:cNvPicPr>
+          <p:nvPr/>
+        </p:nvPicPr>
+        <p:blipFill>
+          <a:blip>
+            <a:extLst>
+              <a:ext uri="{96DAC541-7B7A-43D3-8B79-37D633B846F1}">
+                <asvg:svgBlip xmlns:asvg="http://schemas.microsoft.com/office/drawing/2016/SVG/main" r:embed="rId10"/>
+              </a:ext>
+            </a:extLst>
+          </a:blip>
+          <a:stretch>
+            <a:fillRect/>
+          </a:stretch>
+        </p:blipFill>
+        <p:spPr>
+          <a:xfrm>
+            <a:off x="4924636" y="4083075"/>
+            <a:ext cx="347468" cy="347468"/>
+          </a:xfrm>
+          <a:prstGeom prst="rect">
+            <a:avLst/>
+          </a:prstGeom>
+        </p:spPr>
+      </p:pic>
+      <p:pic>
+        <p:nvPicPr>
+          <p:cNvPr id="61" name="Graphic 60" descr="Rainforest with solid fill">
+            <a:extLst>
+              <a:ext uri="{FF2B5EF4-FFF2-40B4-BE49-F238E27FC236}">
+                <a16:creationId xmlns:a16="http://schemas.microsoft.com/office/drawing/2014/main" id="{DE5DDEF7-A700-B3F8-5112-447FE5B3EF98}"/>
+              </a:ext>
+            </a:extLst>
+          </p:cNvPr>
+          <p:cNvPicPr>
+            <a:picLocks noChangeAspect="1"/>
+          </p:cNvPicPr>
+          <p:nvPr/>
+        </p:nvPicPr>
+        <p:blipFill>
+          <a:blip>
+            <a:extLst>
+              <a:ext uri="{96DAC541-7B7A-43D3-8B79-37D633B846F1}">
+                <asvg:svgBlip xmlns:asvg="http://schemas.microsoft.com/office/drawing/2016/SVG/main" r:embed="rId11"/>
+              </a:ext>
+            </a:extLst>
+          </a:blip>
+          <a:stretch>
+            <a:fillRect/>
+          </a:stretch>
+        </p:blipFill>
+        <p:spPr>
+          <a:xfrm>
+            <a:off x="5272104" y="4094585"/>
+            <a:ext cx="301064" cy="301064"/>
+          </a:xfrm>
+          <a:prstGeom prst="rect">
+            <a:avLst/>
+          </a:prstGeom>
+        </p:spPr>
+      </p:pic>
     </p:spTree>
     <p:extLst>
       <p:ext uri="{BB962C8B-B14F-4D97-AF65-F5344CB8AC3E}">
@@ -4279,7 +4462,1479 @@
 </p:sld>
 </file>
 
-<file path=ppt/slides/slide2.xml><?xml version="1.0" encoding="utf-8"?>
+<file path=ppt/slides/slide3.xml><?xml version="1.0" encoding="utf-8"?>
+<p:sld xmlns:a="http://schemas.openxmlformats.org/drawingml/2006/main" xmlns:r="http://schemas.openxmlformats.org/officeDocument/2006/relationships" xmlns:p="http://schemas.openxmlformats.org/presentationml/2006/main">
+  <p:cSld>
+    <p:spTree>
+      <p:nvGrpSpPr>
+        <p:cNvPr id="1" name="">
+          <a:extLst>
+            <a:ext uri="{FF2B5EF4-FFF2-40B4-BE49-F238E27FC236}">
+              <a16:creationId xmlns:a16="http://schemas.microsoft.com/office/drawing/2014/main" id="{FCB8BC12-5379-5A12-E09F-DF8E25D2B6D9}"/>
+            </a:ext>
+          </a:extLst>
+        </p:cNvPr>
+        <p:cNvGrpSpPr/>
+        <p:nvPr/>
+      </p:nvGrpSpPr>
+      <p:grpSpPr>
+        <a:xfrm>
+          <a:off x="0" y="0"/>
+          <a:ext cx="0" cy="0"/>
+          <a:chOff x="0" y="0"/>
+          <a:chExt cx="0" cy="0"/>
+        </a:xfrm>
+      </p:grpSpPr>
+      <p:pic>
+        <p:nvPicPr>
+          <p:cNvPr id="2" name="Picture 1">
+            <a:extLst>
+              <a:ext uri="{FF2B5EF4-FFF2-40B4-BE49-F238E27FC236}">
+                <a16:creationId xmlns:a16="http://schemas.microsoft.com/office/drawing/2014/main" id="{C10672B6-1808-A82B-5E4A-18E88557B02D}"/>
+              </a:ext>
+            </a:extLst>
+          </p:cNvPr>
+          <p:cNvPicPr/>
+          <p:nvPr/>
+        </p:nvPicPr>
+        <p:blipFill>
+          <a:blip r:embed="rId2">
+            <a:extLst>
+              <a:ext uri="{28A0092B-C50C-407E-A947-70E740481C1C}">
+                <a14:useLocalDpi xmlns:a14="http://schemas.microsoft.com/office/drawing/2010/main" val="0"/>
+              </a:ext>
+            </a:extLst>
+          </a:blip>
+          <a:srcRect/>
+          <a:stretch/>
+        </p:blipFill>
+        <p:spPr>
+          <a:xfrm>
+            <a:off x="173258" y="1402522"/>
+            <a:ext cx="11816514" cy="3938838"/>
+          </a:xfrm>
+          <a:prstGeom prst="rect">
+            <a:avLst/>
+          </a:prstGeom>
+        </p:spPr>
+      </p:pic>
+      <p:sp>
+        <p:nvSpPr>
+          <p:cNvPr id="26" name="TextBox 25">
+            <a:extLst>
+              <a:ext uri="{FF2B5EF4-FFF2-40B4-BE49-F238E27FC236}">
+                <a16:creationId xmlns:a16="http://schemas.microsoft.com/office/drawing/2014/main" id="{E63FFD2C-CDE0-2A7A-B234-34FCB5DF4D85}"/>
+              </a:ext>
+            </a:extLst>
+          </p:cNvPr>
+          <p:cNvSpPr txBox="1">
+            <a:spLocks noGrp="1" noRot="1" noMove="1" noResize="1" noEditPoints="1" noAdjustHandles="1" noChangeArrowheads="1" noChangeShapeType="1"/>
+          </p:cNvSpPr>
+          <p:nvPr/>
+        </p:nvSpPr>
+        <p:spPr>
+          <a:xfrm>
+            <a:off x="1064525" y="1559593"/>
+            <a:ext cx="477672" cy="461665"/>
+          </a:xfrm>
+          <a:prstGeom prst="rect">
+            <a:avLst/>
+          </a:prstGeom>
+          <a:noFill/>
+        </p:spPr>
+        <p:txBody>
+          <a:bodyPr wrap="square" rtlCol="0">
+            <a:spAutoFit/>
+          </a:bodyPr>
+          <a:lstStyle/>
+          <a:p>
+            <a:r>
+              <a:rPr lang="en-US" sz="2400" b="1" dirty="0"/>
+              <a:t>A</a:t>
+            </a:r>
+          </a:p>
+        </p:txBody>
+      </p:sp>
+      <p:sp>
+        <p:nvSpPr>
+          <p:cNvPr id="27" name="TextBox 26">
+            <a:extLst>
+              <a:ext uri="{FF2B5EF4-FFF2-40B4-BE49-F238E27FC236}">
+                <a16:creationId xmlns:a16="http://schemas.microsoft.com/office/drawing/2014/main" id="{ACD9609B-6BE8-B612-BFEC-5979B64D47DF}"/>
+              </a:ext>
+            </a:extLst>
+          </p:cNvPr>
+          <p:cNvSpPr txBox="1">
+            <a:spLocks noGrp="1" noRot="1" noMove="1" noResize="1" noEditPoints="1" noAdjustHandles="1" noChangeArrowheads="1" noChangeShapeType="1"/>
+          </p:cNvSpPr>
+          <p:nvPr/>
+        </p:nvSpPr>
+        <p:spPr>
+          <a:xfrm>
+            <a:off x="4997365" y="1561865"/>
+            <a:ext cx="477672" cy="461665"/>
+          </a:xfrm>
+          <a:prstGeom prst="rect">
+            <a:avLst/>
+          </a:prstGeom>
+          <a:noFill/>
+        </p:spPr>
+        <p:txBody>
+          <a:bodyPr wrap="square" rtlCol="0">
+            <a:spAutoFit/>
+          </a:bodyPr>
+          <a:lstStyle/>
+          <a:p>
+            <a:r>
+              <a:rPr lang="en-US" sz="2400" b="1" dirty="0"/>
+              <a:t>B</a:t>
+            </a:r>
+          </a:p>
+        </p:txBody>
+      </p:sp>
+      <p:sp>
+        <p:nvSpPr>
+          <p:cNvPr id="28" name="TextBox 27">
+            <a:extLst>
+              <a:ext uri="{FF2B5EF4-FFF2-40B4-BE49-F238E27FC236}">
+                <a16:creationId xmlns:a16="http://schemas.microsoft.com/office/drawing/2014/main" id="{C328A9A4-8021-2FE7-A519-A5DDBF8D44B2}"/>
+              </a:ext>
+            </a:extLst>
+          </p:cNvPr>
+          <p:cNvSpPr txBox="1">
+            <a:spLocks noGrp="1" noRot="1" noMove="1" noResize="1" noEditPoints="1" noAdjustHandles="1" noChangeArrowheads="1" noChangeShapeType="1"/>
+          </p:cNvSpPr>
+          <p:nvPr/>
+        </p:nvSpPr>
+        <p:spPr>
+          <a:xfrm>
+            <a:off x="8930201" y="1564137"/>
+            <a:ext cx="477672" cy="461665"/>
+          </a:xfrm>
+          <a:prstGeom prst="rect">
+            <a:avLst/>
+          </a:prstGeom>
+          <a:noFill/>
+        </p:spPr>
+        <p:txBody>
+          <a:bodyPr wrap="square" rtlCol="0">
+            <a:spAutoFit/>
+          </a:bodyPr>
+          <a:lstStyle/>
+          <a:p>
+            <a:r>
+              <a:rPr lang="en-US" sz="2400" b="1" dirty="0"/>
+              <a:t>C</a:t>
+            </a:r>
+          </a:p>
+        </p:txBody>
+      </p:sp>
+      <p:sp>
+        <p:nvSpPr>
+          <p:cNvPr id="23" name="Rectangle 22">
+            <a:extLst>
+              <a:ext uri="{FF2B5EF4-FFF2-40B4-BE49-F238E27FC236}">
+                <a16:creationId xmlns:a16="http://schemas.microsoft.com/office/drawing/2014/main" id="{2A23E950-A293-D243-B47C-5720830F2631}"/>
+              </a:ext>
+            </a:extLst>
+          </p:cNvPr>
+          <p:cNvSpPr/>
+          <p:nvPr/>
+        </p:nvSpPr>
+        <p:spPr>
+          <a:xfrm>
+            <a:off x="4359166" y="3290636"/>
+            <a:ext cx="130069" cy="138364"/>
+          </a:xfrm>
+          <a:prstGeom prst="rect">
+            <a:avLst/>
+          </a:prstGeom>
+          <a:solidFill>
+            <a:schemeClr val="bg1"/>
+          </a:solidFill>
+          <a:ln>
+            <a:solidFill>
+              <a:schemeClr val="bg1"/>
+            </a:solidFill>
+          </a:ln>
+        </p:spPr>
+        <p:style>
+          <a:lnRef idx="2">
+            <a:schemeClr val="accent1">
+              <a:shade val="15000"/>
+            </a:schemeClr>
+          </a:lnRef>
+          <a:fillRef idx="1">
+            <a:schemeClr val="accent1"/>
+          </a:fillRef>
+          <a:effectRef idx="0">
+            <a:schemeClr val="accent1"/>
+          </a:effectRef>
+          <a:fontRef idx="minor">
+            <a:schemeClr val="lt1"/>
+          </a:fontRef>
+        </p:style>
+        <p:txBody>
+          <a:bodyPr rtlCol="0" anchor="ctr"/>
+          <a:lstStyle/>
+          <a:p>
+            <a:pPr algn="ctr"/>
+            <a:endParaRPr lang="en-US"/>
+          </a:p>
+        </p:txBody>
+      </p:sp>
+      <p:pic>
+        <p:nvPicPr>
+          <p:cNvPr id="51" name="Graphic 50" descr="Caterpillar with solid fill">
+            <a:extLst>
+              <a:ext uri="{FF2B5EF4-FFF2-40B4-BE49-F238E27FC236}">
+                <a16:creationId xmlns:a16="http://schemas.microsoft.com/office/drawing/2014/main" id="{8E0513D1-9E71-51D3-0FAD-2388C83794AD}"/>
+              </a:ext>
+            </a:extLst>
+          </p:cNvPr>
+          <p:cNvPicPr>
+            <a:picLocks noChangeAspect="1"/>
+          </p:cNvPicPr>
+          <p:nvPr/>
+        </p:nvPicPr>
+        <p:blipFill>
+          <a:blip>
+            <a:extLst>
+              <a:ext uri="{96DAC541-7B7A-43D3-8B79-37D633B846F1}">
+                <asvg:svgBlip xmlns:asvg="http://schemas.microsoft.com/office/drawing/2016/SVG/main" r:embed="rId3"/>
+              </a:ext>
+            </a:extLst>
+          </a:blip>
+          <a:stretch>
+            <a:fillRect/>
+          </a:stretch>
+        </p:blipFill>
+        <p:spPr>
+          <a:xfrm>
+            <a:off x="11261680" y="4165123"/>
+            <a:ext cx="547638" cy="547638"/>
+          </a:xfrm>
+          <a:prstGeom prst="rect">
+            <a:avLst/>
+          </a:prstGeom>
+        </p:spPr>
+      </p:pic>
+      <p:pic>
+        <p:nvPicPr>
+          <p:cNvPr id="52" name="Graphic 51" descr="Blueberry with solid fill">
+            <a:extLst>
+              <a:ext uri="{FF2B5EF4-FFF2-40B4-BE49-F238E27FC236}">
+                <a16:creationId xmlns:a16="http://schemas.microsoft.com/office/drawing/2014/main" id="{5F92948D-25EC-1FB6-7977-9111389EEC2C}"/>
+              </a:ext>
+            </a:extLst>
+          </p:cNvPr>
+          <p:cNvPicPr>
+            <a:picLocks noChangeAspect="1"/>
+          </p:cNvPicPr>
+          <p:nvPr/>
+        </p:nvPicPr>
+        <p:blipFill>
+          <a:blip>
+            <a:extLst>
+              <a:ext uri="{96DAC541-7B7A-43D3-8B79-37D633B846F1}">
+                <asvg:svgBlip xmlns:asvg="http://schemas.microsoft.com/office/drawing/2016/SVG/main" r:embed="rId4"/>
+              </a:ext>
+            </a:extLst>
+          </a:blip>
+          <a:stretch>
+            <a:fillRect/>
+          </a:stretch>
+        </p:blipFill>
+        <p:spPr>
+          <a:xfrm>
+            <a:off x="8798458" y="4223572"/>
+            <a:ext cx="477672" cy="477672"/>
+          </a:xfrm>
+          <a:prstGeom prst="rect">
+            <a:avLst/>
+          </a:prstGeom>
+        </p:spPr>
+      </p:pic>
+      <p:pic>
+        <p:nvPicPr>
+          <p:cNvPr id="53" name="Graphic 52" descr="Thermometer with solid fill">
+            <a:extLst>
+              <a:ext uri="{FF2B5EF4-FFF2-40B4-BE49-F238E27FC236}">
+                <a16:creationId xmlns:a16="http://schemas.microsoft.com/office/drawing/2014/main" id="{637FC712-63AC-8109-E81C-3A85D34B2540}"/>
+              </a:ext>
+            </a:extLst>
+          </p:cNvPr>
+          <p:cNvPicPr>
+            <a:picLocks noChangeAspect="1"/>
+          </p:cNvPicPr>
+          <p:nvPr/>
+        </p:nvPicPr>
+        <p:blipFill>
+          <a:blip>
+            <a:extLst>
+              <a:ext uri="{96DAC541-7B7A-43D3-8B79-37D633B846F1}">
+                <asvg:svgBlip xmlns:asvg="http://schemas.microsoft.com/office/drawing/2016/SVG/main" r:embed="rId5"/>
+              </a:ext>
+            </a:extLst>
+          </a:blip>
+          <a:stretch>
+            <a:fillRect/>
+          </a:stretch>
+        </p:blipFill>
+        <p:spPr>
+          <a:xfrm>
+            <a:off x="930320" y="4164817"/>
+            <a:ext cx="461665" cy="461665"/>
+          </a:xfrm>
+          <a:prstGeom prst="rect">
+            <a:avLst/>
+          </a:prstGeom>
+        </p:spPr>
+      </p:pic>
+      <p:pic>
+        <p:nvPicPr>
+          <p:cNvPr id="54" name="Graphic 53" descr="Thermometer with solid fill">
+            <a:extLst>
+              <a:ext uri="{FF2B5EF4-FFF2-40B4-BE49-F238E27FC236}">
+                <a16:creationId xmlns:a16="http://schemas.microsoft.com/office/drawing/2014/main" id="{5F0E408F-236B-C338-C60F-DA3AC5780D1A}"/>
+              </a:ext>
+            </a:extLst>
+          </p:cNvPr>
+          <p:cNvPicPr>
+            <a:picLocks noChangeAspect="1"/>
+          </p:cNvPicPr>
+          <p:nvPr/>
+        </p:nvPicPr>
+        <p:blipFill>
+          <a:blip>
+            <a:extLst>
+              <a:ext uri="{96DAC541-7B7A-43D3-8B79-37D633B846F1}">
+                <asvg:svgBlip xmlns:asvg="http://schemas.microsoft.com/office/drawing/2016/SVG/main" r:embed="rId5"/>
+              </a:ext>
+            </a:extLst>
+          </a:blip>
+          <a:stretch>
+            <a:fillRect/>
+          </a:stretch>
+        </p:blipFill>
+        <p:spPr>
+          <a:xfrm>
+            <a:off x="3296370" y="4187422"/>
+            <a:ext cx="461665" cy="461665"/>
+          </a:xfrm>
+          <a:prstGeom prst="rect">
+            <a:avLst/>
+          </a:prstGeom>
+        </p:spPr>
+      </p:pic>
+      <p:pic>
+        <p:nvPicPr>
+          <p:cNvPr id="55" name="Graphic 54" descr="Snowflake with solid fill">
+            <a:extLst>
+              <a:ext uri="{FF2B5EF4-FFF2-40B4-BE49-F238E27FC236}">
+                <a16:creationId xmlns:a16="http://schemas.microsoft.com/office/drawing/2014/main" id="{AB7D3732-66BD-9FFE-8A96-097A92F84F0D}"/>
+              </a:ext>
+            </a:extLst>
+          </p:cNvPr>
+          <p:cNvPicPr>
+            <a:picLocks noChangeAspect="1"/>
+          </p:cNvPicPr>
+          <p:nvPr/>
+        </p:nvPicPr>
+        <p:blipFill>
+          <a:blip>
+            <a:extLst>
+              <a:ext uri="{96DAC541-7B7A-43D3-8B79-37D633B846F1}">
+                <asvg:svgBlip xmlns:asvg="http://schemas.microsoft.com/office/drawing/2016/SVG/main" r:embed="rId6"/>
+              </a:ext>
+            </a:extLst>
+          </a:blip>
+          <a:stretch>
+            <a:fillRect/>
+          </a:stretch>
+        </p:blipFill>
+        <p:spPr>
+          <a:xfrm>
+            <a:off x="1156555" y="4027490"/>
+            <a:ext cx="518987" cy="518987"/>
+          </a:xfrm>
+          <a:prstGeom prst="rect">
+            <a:avLst/>
+          </a:prstGeom>
+        </p:spPr>
+      </p:pic>
+      <p:pic>
+        <p:nvPicPr>
+          <p:cNvPr id="56" name="Graphic 55" descr="Fire with solid fill">
+            <a:extLst>
+              <a:ext uri="{FF2B5EF4-FFF2-40B4-BE49-F238E27FC236}">
+                <a16:creationId xmlns:a16="http://schemas.microsoft.com/office/drawing/2014/main" id="{EA1F0E44-3866-3829-5EEC-E9613E73B4B0}"/>
+              </a:ext>
+            </a:extLst>
+          </p:cNvPr>
+          <p:cNvPicPr>
+            <a:picLocks noChangeAspect="1"/>
+          </p:cNvPicPr>
+          <p:nvPr/>
+        </p:nvPicPr>
+        <p:blipFill>
+          <a:blip>
+            <a:extLst>
+              <a:ext uri="{96DAC541-7B7A-43D3-8B79-37D633B846F1}">
+                <asvg:svgBlip xmlns:asvg="http://schemas.microsoft.com/office/drawing/2016/SVG/main" r:embed="rId7"/>
+              </a:ext>
+            </a:extLst>
+          </a:blip>
+          <a:stretch>
+            <a:fillRect/>
+          </a:stretch>
+        </p:blipFill>
+        <p:spPr>
+          <a:xfrm>
+            <a:off x="3527203" y="4003428"/>
+            <a:ext cx="461665" cy="461665"/>
+          </a:xfrm>
+          <a:prstGeom prst="rect">
+            <a:avLst/>
+          </a:prstGeom>
+        </p:spPr>
+      </p:pic>
+      <p:pic>
+        <p:nvPicPr>
+          <p:cNvPr id="57" name="Graphic 56" descr="Forest scene with solid fill">
+            <a:extLst>
+              <a:ext uri="{FF2B5EF4-FFF2-40B4-BE49-F238E27FC236}">
+                <a16:creationId xmlns:a16="http://schemas.microsoft.com/office/drawing/2014/main" id="{7CE2D43C-8CE0-D57E-4D62-3574A53AB6AB}"/>
+              </a:ext>
+            </a:extLst>
+          </p:cNvPr>
+          <p:cNvPicPr>
+            <a:picLocks noChangeAspect="1"/>
+          </p:cNvPicPr>
+          <p:nvPr/>
+        </p:nvPicPr>
+        <p:blipFill>
+          <a:blip>
+            <a:extLst>
+              <a:ext uri="{96DAC541-7B7A-43D3-8B79-37D633B846F1}">
+                <asvg:svgBlip xmlns:asvg="http://schemas.microsoft.com/office/drawing/2016/SVG/main" r:embed="rId8"/>
+              </a:ext>
+            </a:extLst>
+          </a:blip>
+          <a:stretch>
+            <a:fillRect/>
+          </a:stretch>
+        </p:blipFill>
+        <p:spPr>
+          <a:xfrm>
+            <a:off x="7216505" y="3998828"/>
+            <a:ext cx="692975" cy="692975"/>
+          </a:xfrm>
+          <a:prstGeom prst="rect">
+            <a:avLst/>
+          </a:prstGeom>
+        </p:spPr>
+      </p:pic>
+      <p:pic>
+        <p:nvPicPr>
+          <p:cNvPr id="58" name="Graphic 57" descr="Forest scene with solid fill">
+            <a:extLst>
+              <a:ext uri="{FF2B5EF4-FFF2-40B4-BE49-F238E27FC236}">
+                <a16:creationId xmlns:a16="http://schemas.microsoft.com/office/drawing/2014/main" id="{2250B113-FFBC-F34A-31AB-539F7E929140}"/>
+              </a:ext>
+            </a:extLst>
+          </p:cNvPr>
+          <p:cNvPicPr>
+            <a:picLocks noChangeAspect="1"/>
+          </p:cNvPicPr>
+          <p:nvPr/>
+        </p:nvPicPr>
+        <p:blipFill>
+          <a:blip>
+            <a:extLst>
+              <a:ext uri="{96DAC541-7B7A-43D3-8B79-37D633B846F1}">
+                <asvg:svgBlip xmlns:asvg="http://schemas.microsoft.com/office/drawing/2016/SVG/main" r:embed="rId8"/>
+              </a:ext>
+            </a:extLst>
+          </a:blip>
+          <a:stretch>
+            <a:fillRect/>
+          </a:stretch>
+        </p:blipFill>
+        <p:spPr>
+          <a:xfrm>
+            <a:off x="4934844" y="4337050"/>
+            <a:ext cx="345643" cy="345643"/>
+          </a:xfrm>
+          <a:prstGeom prst="rect">
+            <a:avLst/>
+          </a:prstGeom>
+        </p:spPr>
+      </p:pic>
+      <p:pic>
+        <p:nvPicPr>
+          <p:cNvPr id="59" name="Graphic 58" descr="Crops with solid fill">
+            <a:extLst>
+              <a:ext uri="{FF2B5EF4-FFF2-40B4-BE49-F238E27FC236}">
+                <a16:creationId xmlns:a16="http://schemas.microsoft.com/office/drawing/2014/main" id="{F30EB79E-7AFE-0837-2013-CF5976B5C38C}"/>
+              </a:ext>
+            </a:extLst>
+          </p:cNvPr>
+          <p:cNvPicPr>
+            <a:picLocks noChangeAspect="1"/>
+          </p:cNvPicPr>
+          <p:nvPr/>
+        </p:nvPicPr>
+        <p:blipFill>
+          <a:blip>
+            <a:extLst>
+              <a:ext uri="{96DAC541-7B7A-43D3-8B79-37D633B846F1}">
+                <asvg:svgBlip xmlns:asvg="http://schemas.microsoft.com/office/drawing/2016/SVG/main" r:embed="rId9"/>
+              </a:ext>
+            </a:extLst>
+          </a:blip>
+          <a:stretch>
+            <a:fillRect/>
+          </a:stretch>
+        </p:blipFill>
+        <p:spPr>
+          <a:xfrm>
+            <a:off x="5255252" y="4330700"/>
+            <a:ext cx="347468" cy="347468"/>
+          </a:xfrm>
+          <a:prstGeom prst="rect">
+            <a:avLst/>
+          </a:prstGeom>
+        </p:spPr>
+      </p:pic>
+      <p:pic>
+        <p:nvPicPr>
+          <p:cNvPr id="60" name="Graphic 59" descr="City with solid fill">
+            <a:extLst>
+              <a:ext uri="{FF2B5EF4-FFF2-40B4-BE49-F238E27FC236}">
+                <a16:creationId xmlns:a16="http://schemas.microsoft.com/office/drawing/2014/main" id="{0E893EAB-5E19-580C-75AD-2307CB6CF724}"/>
+              </a:ext>
+            </a:extLst>
+          </p:cNvPr>
+          <p:cNvPicPr>
+            <a:picLocks noChangeAspect="1"/>
+          </p:cNvPicPr>
+          <p:nvPr/>
+        </p:nvPicPr>
+        <p:blipFill>
+          <a:blip>
+            <a:extLst>
+              <a:ext uri="{96DAC541-7B7A-43D3-8B79-37D633B846F1}">
+                <asvg:svgBlip xmlns:asvg="http://schemas.microsoft.com/office/drawing/2016/SVG/main" r:embed="rId10"/>
+              </a:ext>
+            </a:extLst>
+          </a:blip>
+          <a:stretch>
+            <a:fillRect/>
+          </a:stretch>
+        </p:blipFill>
+        <p:spPr>
+          <a:xfrm>
+            <a:off x="4924636" y="4083075"/>
+            <a:ext cx="347468" cy="347468"/>
+          </a:xfrm>
+          <a:prstGeom prst="rect">
+            <a:avLst/>
+          </a:prstGeom>
+        </p:spPr>
+      </p:pic>
+      <p:pic>
+        <p:nvPicPr>
+          <p:cNvPr id="61" name="Graphic 60" descr="Rainforest with solid fill">
+            <a:extLst>
+              <a:ext uri="{FF2B5EF4-FFF2-40B4-BE49-F238E27FC236}">
+                <a16:creationId xmlns:a16="http://schemas.microsoft.com/office/drawing/2014/main" id="{944F2A20-0829-0F13-2D4C-C59D5212B7A1}"/>
+              </a:ext>
+            </a:extLst>
+          </p:cNvPr>
+          <p:cNvPicPr>
+            <a:picLocks noChangeAspect="1"/>
+          </p:cNvPicPr>
+          <p:nvPr/>
+        </p:nvPicPr>
+        <p:blipFill>
+          <a:blip>
+            <a:extLst>
+              <a:ext uri="{96DAC541-7B7A-43D3-8B79-37D633B846F1}">
+                <asvg:svgBlip xmlns:asvg="http://schemas.microsoft.com/office/drawing/2016/SVG/main" r:embed="rId11"/>
+              </a:ext>
+            </a:extLst>
+          </a:blip>
+          <a:stretch>
+            <a:fillRect/>
+          </a:stretch>
+        </p:blipFill>
+        <p:spPr>
+          <a:xfrm>
+            <a:off x="5272104" y="4094585"/>
+            <a:ext cx="301064" cy="301064"/>
+          </a:xfrm>
+          <a:prstGeom prst="rect">
+            <a:avLst/>
+          </a:prstGeom>
+        </p:spPr>
+      </p:pic>
+    </p:spTree>
+    <p:extLst>
+      <p:ext uri="{BB962C8B-B14F-4D97-AF65-F5344CB8AC3E}">
+        <p14:creationId xmlns:p14="http://schemas.microsoft.com/office/powerpoint/2010/main" val="2033639568"/>
+      </p:ext>
+    </p:extLst>
+  </p:cSld>
+  <p:clrMapOvr>
+    <a:masterClrMapping/>
+  </p:clrMapOvr>
+</p:sld>
+</file>
+
+<file path=ppt/slides/slide4.xml><?xml version="1.0" encoding="utf-8"?>
+<p:sld xmlns:a="http://schemas.openxmlformats.org/drawingml/2006/main" xmlns:r="http://schemas.openxmlformats.org/officeDocument/2006/relationships" xmlns:p="http://schemas.openxmlformats.org/presentationml/2006/main">
+  <p:cSld>
+    <p:spTree>
+      <p:nvGrpSpPr>
+        <p:cNvPr id="1" name="">
+          <a:extLst>
+            <a:ext uri="{FF2B5EF4-FFF2-40B4-BE49-F238E27FC236}">
+              <a16:creationId xmlns:a16="http://schemas.microsoft.com/office/drawing/2014/main" id="{1018D0CC-40CF-6F0A-FACF-68ED856DF25D}"/>
+            </a:ext>
+          </a:extLst>
+        </p:cNvPr>
+        <p:cNvGrpSpPr/>
+        <p:nvPr/>
+      </p:nvGrpSpPr>
+      <p:grpSpPr>
+        <a:xfrm>
+          <a:off x="0" y="0"/>
+          <a:ext cx="0" cy="0"/>
+          <a:chOff x="0" y="0"/>
+          <a:chExt cx="0" cy="0"/>
+        </a:xfrm>
+      </p:grpSpPr>
+      <p:pic>
+        <p:nvPicPr>
+          <p:cNvPr id="5" name="Picture 4">
+            <a:extLst>
+              <a:ext uri="{FF2B5EF4-FFF2-40B4-BE49-F238E27FC236}">
+                <a16:creationId xmlns:a16="http://schemas.microsoft.com/office/drawing/2014/main" id="{042C3ADA-EB9E-36F6-BE47-069286FF1010}"/>
+              </a:ext>
+            </a:extLst>
+          </p:cNvPr>
+          <p:cNvPicPr>
+            <a:picLocks noGrp="1" noRot="1" noChangeAspect="1" noMove="1" noResize="1" noEditPoints="1" noAdjustHandles="1" noChangeArrowheads="1" noChangeShapeType="1" noCrop="1"/>
+          </p:cNvPicPr>
+          <p:nvPr/>
+        </p:nvPicPr>
+        <p:blipFill>
+          <a:blip r:embed="rId2">
+            <a:extLst>
+              <a:ext uri="{28A0092B-C50C-407E-A947-70E740481C1C}">
+                <a14:useLocalDpi xmlns:a14="http://schemas.microsoft.com/office/drawing/2010/main" val="0"/>
+              </a:ext>
+            </a:extLst>
+          </a:blip>
+          <a:srcRect/>
+          <a:stretch/>
+        </p:blipFill>
+        <p:spPr>
+          <a:xfrm>
+            <a:off x="169720" y="1398984"/>
+            <a:ext cx="11816514" cy="3938838"/>
+          </a:xfrm>
+          <a:prstGeom prst="rect">
+            <a:avLst/>
+          </a:prstGeom>
+        </p:spPr>
+      </p:pic>
+      <p:sp>
+        <p:nvSpPr>
+          <p:cNvPr id="26" name="TextBox 25">
+            <a:extLst>
+              <a:ext uri="{FF2B5EF4-FFF2-40B4-BE49-F238E27FC236}">
+                <a16:creationId xmlns:a16="http://schemas.microsoft.com/office/drawing/2014/main" id="{A46062AD-1728-D5BF-F4A7-A1098F664074}"/>
+              </a:ext>
+            </a:extLst>
+          </p:cNvPr>
+          <p:cNvSpPr txBox="1">
+            <a:spLocks noGrp="1" noRot="1" noMove="1" noResize="1" noEditPoints="1" noAdjustHandles="1" noChangeArrowheads="1" noChangeShapeType="1"/>
+          </p:cNvSpPr>
+          <p:nvPr/>
+        </p:nvSpPr>
+        <p:spPr>
+          <a:xfrm>
+            <a:off x="1064525" y="1559593"/>
+            <a:ext cx="477672" cy="461665"/>
+          </a:xfrm>
+          <a:prstGeom prst="rect">
+            <a:avLst/>
+          </a:prstGeom>
+          <a:noFill/>
+        </p:spPr>
+        <p:txBody>
+          <a:bodyPr wrap="square" rtlCol="0">
+            <a:spAutoFit/>
+          </a:bodyPr>
+          <a:lstStyle/>
+          <a:p>
+            <a:r>
+              <a:rPr lang="en-US" sz="2400" b="1" dirty="0"/>
+              <a:t>A</a:t>
+            </a:r>
+          </a:p>
+        </p:txBody>
+      </p:sp>
+      <p:sp>
+        <p:nvSpPr>
+          <p:cNvPr id="27" name="TextBox 26">
+            <a:extLst>
+              <a:ext uri="{FF2B5EF4-FFF2-40B4-BE49-F238E27FC236}">
+                <a16:creationId xmlns:a16="http://schemas.microsoft.com/office/drawing/2014/main" id="{CC4A062F-DF74-0F1A-8B2F-C4975BE12D41}"/>
+              </a:ext>
+            </a:extLst>
+          </p:cNvPr>
+          <p:cNvSpPr txBox="1">
+            <a:spLocks noGrp="1" noRot="1" noMove="1" noResize="1" noEditPoints="1" noAdjustHandles="1" noChangeArrowheads="1" noChangeShapeType="1"/>
+          </p:cNvSpPr>
+          <p:nvPr/>
+        </p:nvSpPr>
+        <p:spPr>
+          <a:xfrm>
+            <a:off x="4997365" y="1561865"/>
+            <a:ext cx="477672" cy="461665"/>
+          </a:xfrm>
+          <a:prstGeom prst="rect">
+            <a:avLst/>
+          </a:prstGeom>
+          <a:noFill/>
+        </p:spPr>
+        <p:txBody>
+          <a:bodyPr wrap="square" rtlCol="0">
+            <a:spAutoFit/>
+          </a:bodyPr>
+          <a:lstStyle/>
+          <a:p>
+            <a:r>
+              <a:rPr lang="en-US" sz="2400" b="1" dirty="0"/>
+              <a:t>B</a:t>
+            </a:r>
+          </a:p>
+        </p:txBody>
+      </p:sp>
+      <p:sp>
+        <p:nvSpPr>
+          <p:cNvPr id="28" name="TextBox 27">
+            <a:extLst>
+              <a:ext uri="{FF2B5EF4-FFF2-40B4-BE49-F238E27FC236}">
+                <a16:creationId xmlns:a16="http://schemas.microsoft.com/office/drawing/2014/main" id="{2D6574F9-08C7-10D4-5499-D48FD4F92FE7}"/>
+              </a:ext>
+            </a:extLst>
+          </p:cNvPr>
+          <p:cNvSpPr txBox="1">
+            <a:spLocks noGrp="1" noRot="1" noMove="1" noResize="1" noEditPoints="1" noAdjustHandles="1" noChangeArrowheads="1" noChangeShapeType="1"/>
+          </p:cNvSpPr>
+          <p:nvPr/>
+        </p:nvSpPr>
+        <p:spPr>
+          <a:xfrm>
+            <a:off x="8930201" y="1564137"/>
+            <a:ext cx="477672" cy="461665"/>
+          </a:xfrm>
+          <a:prstGeom prst="rect">
+            <a:avLst/>
+          </a:prstGeom>
+          <a:noFill/>
+        </p:spPr>
+        <p:txBody>
+          <a:bodyPr wrap="square" rtlCol="0">
+            <a:spAutoFit/>
+          </a:bodyPr>
+          <a:lstStyle/>
+          <a:p>
+            <a:r>
+              <a:rPr lang="en-US" sz="2400" b="1" dirty="0"/>
+              <a:t>C</a:t>
+            </a:r>
+          </a:p>
+        </p:txBody>
+      </p:sp>
+      <p:sp>
+        <p:nvSpPr>
+          <p:cNvPr id="23" name="Rectangle 22">
+            <a:extLst>
+              <a:ext uri="{FF2B5EF4-FFF2-40B4-BE49-F238E27FC236}">
+                <a16:creationId xmlns:a16="http://schemas.microsoft.com/office/drawing/2014/main" id="{382E750F-B904-361B-EE71-B7A7555D77E1}"/>
+              </a:ext>
+            </a:extLst>
+          </p:cNvPr>
+          <p:cNvSpPr/>
+          <p:nvPr/>
+        </p:nvSpPr>
+        <p:spPr>
+          <a:xfrm>
+            <a:off x="4359166" y="3290636"/>
+            <a:ext cx="130069" cy="138364"/>
+          </a:xfrm>
+          <a:prstGeom prst="rect">
+            <a:avLst/>
+          </a:prstGeom>
+          <a:solidFill>
+            <a:schemeClr val="bg1"/>
+          </a:solidFill>
+          <a:ln>
+            <a:solidFill>
+              <a:schemeClr val="bg1"/>
+            </a:solidFill>
+          </a:ln>
+        </p:spPr>
+        <p:style>
+          <a:lnRef idx="2">
+            <a:schemeClr val="accent1">
+              <a:shade val="15000"/>
+            </a:schemeClr>
+          </a:lnRef>
+          <a:fillRef idx="1">
+            <a:schemeClr val="accent1"/>
+          </a:fillRef>
+          <a:effectRef idx="0">
+            <a:schemeClr val="accent1"/>
+          </a:effectRef>
+          <a:fontRef idx="minor">
+            <a:schemeClr val="lt1"/>
+          </a:fontRef>
+        </p:style>
+        <p:txBody>
+          <a:bodyPr rtlCol="0" anchor="ctr"/>
+          <a:lstStyle/>
+          <a:p>
+            <a:pPr algn="ctr"/>
+            <a:endParaRPr lang="en-US"/>
+          </a:p>
+        </p:txBody>
+      </p:sp>
+      <p:pic>
+        <p:nvPicPr>
+          <p:cNvPr id="4" name="Graphic 3" descr="Caterpillar with solid fill">
+            <a:extLst>
+              <a:ext uri="{FF2B5EF4-FFF2-40B4-BE49-F238E27FC236}">
+                <a16:creationId xmlns:a16="http://schemas.microsoft.com/office/drawing/2014/main" id="{0E56F6DB-E5DE-D7AF-C26C-DC8844BEF8BA}"/>
+              </a:ext>
+            </a:extLst>
+          </p:cNvPr>
+          <p:cNvPicPr>
+            <a:picLocks noChangeAspect="1"/>
+          </p:cNvPicPr>
+          <p:nvPr/>
+        </p:nvPicPr>
+        <p:blipFill>
+          <a:blip>
+            <a:extLst>
+              <a:ext uri="{96DAC541-7B7A-43D3-8B79-37D633B846F1}">
+                <asvg:svgBlip xmlns:asvg="http://schemas.microsoft.com/office/drawing/2016/SVG/main" r:embed="rId3"/>
+              </a:ext>
+            </a:extLst>
+          </a:blip>
+          <a:stretch>
+            <a:fillRect/>
+          </a:stretch>
+        </p:blipFill>
+        <p:spPr>
+          <a:xfrm>
+            <a:off x="11261680" y="4165123"/>
+            <a:ext cx="547638" cy="547638"/>
+          </a:xfrm>
+          <a:prstGeom prst="rect">
+            <a:avLst/>
+          </a:prstGeom>
+        </p:spPr>
+      </p:pic>
+      <p:pic>
+        <p:nvPicPr>
+          <p:cNvPr id="25" name="Graphic 24" descr="Blueberry with solid fill">
+            <a:extLst>
+              <a:ext uri="{FF2B5EF4-FFF2-40B4-BE49-F238E27FC236}">
+                <a16:creationId xmlns:a16="http://schemas.microsoft.com/office/drawing/2014/main" id="{82C62705-B478-EC31-79C7-2574DDC7CD48}"/>
+              </a:ext>
+            </a:extLst>
+          </p:cNvPr>
+          <p:cNvPicPr>
+            <a:picLocks noChangeAspect="1"/>
+          </p:cNvPicPr>
+          <p:nvPr/>
+        </p:nvPicPr>
+        <p:blipFill>
+          <a:blip>
+            <a:extLst>
+              <a:ext uri="{96DAC541-7B7A-43D3-8B79-37D633B846F1}">
+                <asvg:svgBlip xmlns:asvg="http://schemas.microsoft.com/office/drawing/2016/SVG/main" r:embed="rId4"/>
+              </a:ext>
+            </a:extLst>
+          </a:blip>
+          <a:stretch>
+            <a:fillRect/>
+          </a:stretch>
+        </p:blipFill>
+        <p:spPr>
+          <a:xfrm>
+            <a:off x="8798458" y="4223572"/>
+            <a:ext cx="477672" cy="477672"/>
+          </a:xfrm>
+          <a:prstGeom prst="rect">
+            <a:avLst/>
+          </a:prstGeom>
+        </p:spPr>
+      </p:pic>
+      <p:pic>
+        <p:nvPicPr>
+          <p:cNvPr id="31" name="Graphic 30" descr="Thermometer with solid fill">
+            <a:extLst>
+              <a:ext uri="{FF2B5EF4-FFF2-40B4-BE49-F238E27FC236}">
+                <a16:creationId xmlns:a16="http://schemas.microsoft.com/office/drawing/2014/main" id="{02D8507C-1CB7-0287-DF1D-C426237CF9E7}"/>
+              </a:ext>
+            </a:extLst>
+          </p:cNvPr>
+          <p:cNvPicPr>
+            <a:picLocks noChangeAspect="1"/>
+          </p:cNvPicPr>
+          <p:nvPr/>
+        </p:nvPicPr>
+        <p:blipFill>
+          <a:blip>
+            <a:extLst>
+              <a:ext uri="{96DAC541-7B7A-43D3-8B79-37D633B846F1}">
+                <asvg:svgBlip xmlns:asvg="http://schemas.microsoft.com/office/drawing/2016/SVG/main" r:embed="rId5"/>
+              </a:ext>
+            </a:extLst>
+          </a:blip>
+          <a:stretch>
+            <a:fillRect/>
+          </a:stretch>
+        </p:blipFill>
+        <p:spPr>
+          <a:xfrm>
+            <a:off x="930320" y="4164817"/>
+            <a:ext cx="461665" cy="461665"/>
+          </a:xfrm>
+          <a:prstGeom prst="rect">
+            <a:avLst/>
+          </a:prstGeom>
+        </p:spPr>
+      </p:pic>
+      <p:pic>
+        <p:nvPicPr>
+          <p:cNvPr id="32" name="Graphic 31" descr="Thermometer with solid fill">
+            <a:extLst>
+              <a:ext uri="{FF2B5EF4-FFF2-40B4-BE49-F238E27FC236}">
+                <a16:creationId xmlns:a16="http://schemas.microsoft.com/office/drawing/2014/main" id="{51E1DA8D-A450-32E1-0975-8E935C5A0FE2}"/>
+              </a:ext>
+            </a:extLst>
+          </p:cNvPr>
+          <p:cNvPicPr>
+            <a:picLocks noChangeAspect="1"/>
+          </p:cNvPicPr>
+          <p:nvPr/>
+        </p:nvPicPr>
+        <p:blipFill>
+          <a:blip>
+            <a:extLst>
+              <a:ext uri="{96DAC541-7B7A-43D3-8B79-37D633B846F1}">
+                <asvg:svgBlip xmlns:asvg="http://schemas.microsoft.com/office/drawing/2016/SVG/main" r:embed="rId6"/>
+              </a:ext>
+            </a:extLst>
+          </a:blip>
+          <a:stretch>
+            <a:fillRect/>
+          </a:stretch>
+        </p:blipFill>
+        <p:spPr>
+          <a:xfrm>
+            <a:off x="3296370" y="4187422"/>
+            <a:ext cx="461665" cy="461665"/>
+          </a:xfrm>
+          <a:prstGeom prst="rect">
+            <a:avLst/>
+          </a:prstGeom>
+        </p:spPr>
+      </p:pic>
+      <p:pic>
+        <p:nvPicPr>
+          <p:cNvPr id="34" name="Graphic 33" descr="Snowflake with solid fill">
+            <a:extLst>
+              <a:ext uri="{FF2B5EF4-FFF2-40B4-BE49-F238E27FC236}">
+                <a16:creationId xmlns:a16="http://schemas.microsoft.com/office/drawing/2014/main" id="{FA1C7EBE-2AE1-B9BC-7013-354DF59F734B}"/>
+              </a:ext>
+            </a:extLst>
+          </p:cNvPr>
+          <p:cNvPicPr>
+            <a:picLocks noChangeAspect="1"/>
+          </p:cNvPicPr>
+          <p:nvPr/>
+        </p:nvPicPr>
+        <p:blipFill>
+          <a:blip>
+            <a:extLst>
+              <a:ext uri="{96DAC541-7B7A-43D3-8B79-37D633B846F1}">
+                <asvg:svgBlip xmlns:asvg="http://schemas.microsoft.com/office/drawing/2016/SVG/main" r:embed="rId7"/>
+              </a:ext>
+            </a:extLst>
+          </a:blip>
+          <a:stretch>
+            <a:fillRect/>
+          </a:stretch>
+        </p:blipFill>
+        <p:spPr>
+          <a:xfrm>
+            <a:off x="1156555" y="4027490"/>
+            <a:ext cx="518987" cy="518987"/>
+          </a:xfrm>
+          <a:prstGeom prst="rect">
+            <a:avLst/>
+          </a:prstGeom>
+        </p:spPr>
+      </p:pic>
+      <p:pic>
+        <p:nvPicPr>
+          <p:cNvPr id="36" name="Graphic 35" descr="Fire with solid fill">
+            <a:extLst>
+              <a:ext uri="{FF2B5EF4-FFF2-40B4-BE49-F238E27FC236}">
+                <a16:creationId xmlns:a16="http://schemas.microsoft.com/office/drawing/2014/main" id="{CCFC9232-42FF-A695-D601-B6A24691C88B}"/>
+              </a:ext>
+            </a:extLst>
+          </p:cNvPr>
+          <p:cNvPicPr>
+            <a:picLocks noChangeAspect="1"/>
+          </p:cNvPicPr>
+          <p:nvPr/>
+        </p:nvPicPr>
+        <p:blipFill>
+          <a:blip>
+            <a:extLst>
+              <a:ext uri="{96DAC541-7B7A-43D3-8B79-37D633B846F1}">
+                <asvg:svgBlip xmlns:asvg="http://schemas.microsoft.com/office/drawing/2016/SVG/main" r:embed="rId8"/>
+              </a:ext>
+            </a:extLst>
+          </a:blip>
+          <a:stretch>
+            <a:fillRect/>
+          </a:stretch>
+        </p:blipFill>
+        <p:spPr>
+          <a:xfrm>
+            <a:off x="3527203" y="4003428"/>
+            <a:ext cx="461665" cy="461665"/>
+          </a:xfrm>
+          <a:prstGeom prst="rect">
+            <a:avLst/>
+          </a:prstGeom>
+        </p:spPr>
+      </p:pic>
+      <p:pic>
+        <p:nvPicPr>
+          <p:cNvPr id="3" name="Graphic 2" descr="Forest scene with solid fill">
+            <a:extLst>
+              <a:ext uri="{FF2B5EF4-FFF2-40B4-BE49-F238E27FC236}">
+                <a16:creationId xmlns:a16="http://schemas.microsoft.com/office/drawing/2014/main" id="{711C556B-6ABC-8776-C95B-12D304050E93}"/>
+              </a:ext>
+            </a:extLst>
+          </p:cNvPr>
+          <p:cNvPicPr>
+            <a:picLocks noChangeAspect="1"/>
+          </p:cNvPicPr>
+          <p:nvPr/>
+        </p:nvPicPr>
+        <p:blipFill>
+          <a:blip>
+            <a:extLst>
+              <a:ext uri="{96DAC541-7B7A-43D3-8B79-37D633B846F1}">
+                <asvg:svgBlip xmlns:asvg="http://schemas.microsoft.com/office/drawing/2016/SVG/main" r:embed="rId9"/>
+              </a:ext>
+            </a:extLst>
+          </a:blip>
+          <a:stretch>
+            <a:fillRect/>
+          </a:stretch>
+        </p:blipFill>
+        <p:spPr>
+          <a:xfrm>
+            <a:off x="7216505" y="3998828"/>
+            <a:ext cx="692975" cy="692975"/>
+          </a:xfrm>
+          <a:prstGeom prst="rect">
+            <a:avLst/>
+          </a:prstGeom>
+        </p:spPr>
+      </p:pic>
+      <p:pic>
+        <p:nvPicPr>
+          <p:cNvPr id="6" name="Graphic 5" descr="Forest scene with solid fill">
+            <a:extLst>
+              <a:ext uri="{FF2B5EF4-FFF2-40B4-BE49-F238E27FC236}">
+                <a16:creationId xmlns:a16="http://schemas.microsoft.com/office/drawing/2014/main" id="{371A3332-17FE-FF45-6CFF-1B879E30F854}"/>
+              </a:ext>
+            </a:extLst>
+          </p:cNvPr>
+          <p:cNvPicPr>
+            <a:picLocks noChangeAspect="1"/>
+          </p:cNvPicPr>
+          <p:nvPr/>
+        </p:nvPicPr>
+        <p:blipFill>
+          <a:blip>
+            <a:extLst>
+              <a:ext uri="{96DAC541-7B7A-43D3-8B79-37D633B846F1}">
+                <asvg:svgBlip xmlns:asvg="http://schemas.microsoft.com/office/drawing/2016/SVG/main" r:embed="rId9"/>
+              </a:ext>
+            </a:extLst>
+          </a:blip>
+          <a:stretch>
+            <a:fillRect/>
+          </a:stretch>
+        </p:blipFill>
+        <p:spPr>
+          <a:xfrm>
+            <a:off x="4934844" y="4337050"/>
+            <a:ext cx="345643" cy="345643"/>
+          </a:xfrm>
+          <a:prstGeom prst="rect">
+            <a:avLst/>
+          </a:prstGeom>
+        </p:spPr>
+      </p:pic>
+      <p:pic>
+        <p:nvPicPr>
+          <p:cNvPr id="35" name="Graphic 34" descr="Crops with solid fill">
+            <a:extLst>
+              <a:ext uri="{FF2B5EF4-FFF2-40B4-BE49-F238E27FC236}">
+                <a16:creationId xmlns:a16="http://schemas.microsoft.com/office/drawing/2014/main" id="{55F4466F-E9E2-E9F0-16F6-F64F935B522E}"/>
+              </a:ext>
+            </a:extLst>
+          </p:cNvPr>
+          <p:cNvPicPr>
+            <a:picLocks noChangeAspect="1"/>
+          </p:cNvPicPr>
+          <p:nvPr/>
+        </p:nvPicPr>
+        <p:blipFill>
+          <a:blip>
+            <a:extLst>
+              <a:ext uri="{96DAC541-7B7A-43D3-8B79-37D633B846F1}">
+                <asvg:svgBlip xmlns:asvg="http://schemas.microsoft.com/office/drawing/2016/SVG/main" r:embed="rId10"/>
+              </a:ext>
+            </a:extLst>
+          </a:blip>
+          <a:stretch>
+            <a:fillRect/>
+          </a:stretch>
+        </p:blipFill>
+        <p:spPr>
+          <a:xfrm>
+            <a:off x="5255252" y="4330700"/>
+            <a:ext cx="347468" cy="347468"/>
+          </a:xfrm>
+          <a:prstGeom prst="rect">
+            <a:avLst/>
+          </a:prstGeom>
+        </p:spPr>
+      </p:pic>
+      <p:pic>
+        <p:nvPicPr>
+          <p:cNvPr id="38" name="Graphic 37" descr="City with solid fill">
+            <a:extLst>
+              <a:ext uri="{FF2B5EF4-FFF2-40B4-BE49-F238E27FC236}">
+                <a16:creationId xmlns:a16="http://schemas.microsoft.com/office/drawing/2014/main" id="{46DF256E-0D4B-CCC7-4FB0-FF8FDCCB07D4}"/>
+              </a:ext>
+            </a:extLst>
+          </p:cNvPr>
+          <p:cNvPicPr>
+            <a:picLocks noChangeAspect="1"/>
+          </p:cNvPicPr>
+          <p:nvPr/>
+        </p:nvPicPr>
+        <p:blipFill>
+          <a:blip>
+            <a:extLst>
+              <a:ext uri="{96DAC541-7B7A-43D3-8B79-37D633B846F1}">
+                <asvg:svgBlip xmlns:asvg="http://schemas.microsoft.com/office/drawing/2016/SVG/main" r:embed="rId11"/>
+              </a:ext>
+            </a:extLst>
+          </a:blip>
+          <a:stretch>
+            <a:fillRect/>
+          </a:stretch>
+        </p:blipFill>
+        <p:spPr>
+          <a:xfrm>
+            <a:off x="4924636" y="4083075"/>
+            <a:ext cx="347468" cy="347468"/>
+          </a:xfrm>
+          <a:prstGeom prst="rect">
+            <a:avLst/>
+          </a:prstGeom>
+        </p:spPr>
+      </p:pic>
+      <p:pic>
+        <p:nvPicPr>
+          <p:cNvPr id="40" name="Graphic 39" descr="Rainforest with solid fill">
+            <a:extLst>
+              <a:ext uri="{FF2B5EF4-FFF2-40B4-BE49-F238E27FC236}">
+                <a16:creationId xmlns:a16="http://schemas.microsoft.com/office/drawing/2014/main" id="{A842228B-7849-6092-0D0C-A05B5DE7AA00}"/>
+              </a:ext>
+            </a:extLst>
+          </p:cNvPr>
+          <p:cNvPicPr>
+            <a:picLocks noChangeAspect="1"/>
+          </p:cNvPicPr>
+          <p:nvPr/>
+        </p:nvPicPr>
+        <p:blipFill>
+          <a:blip>
+            <a:extLst>
+              <a:ext uri="{96DAC541-7B7A-43D3-8B79-37D633B846F1}">
+                <asvg:svgBlip xmlns:asvg="http://schemas.microsoft.com/office/drawing/2016/SVG/main" r:embed="rId12"/>
+              </a:ext>
+            </a:extLst>
+          </a:blip>
+          <a:stretch>
+            <a:fillRect/>
+          </a:stretch>
+        </p:blipFill>
+        <p:spPr>
+          <a:xfrm>
+            <a:off x="5272104" y="4094585"/>
+            <a:ext cx="301064" cy="301064"/>
+          </a:xfrm>
+          <a:prstGeom prst="rect">
+            <a:avLst/>
+          </a:prstGeom>
+        </p:spPr>
+      </p:pic>
+    </p:spTree>
+    <p:extLst>
+      <p:ext uri="{BB962C8B-B14F-4D97-AF65-F5344CB8AC3E}">
+        <p14:creationId xmlns:p14="http://schemas.microsoft.com/office/powerpoint/2010/main" val="2000721277"/>
+      </p:ext>
+    </p:extLst>
+  </p:cSld>
+  <p:clrMapOvr>
+    <a:masterClrMapping/>
+  </p:clrMapOvr>
+</p:sld>
+</file>
+
+<file path=ppt/slides/slide5.xml><?xml version="1.0" encoding="utf-8"?>
+<p:sld xmlns:a="http://schemas.openxmlformats.org/drawingml/2006/main" xmlns:r="http://schemas.openxmlformats.org/officeDocument/2006/relationships" xmlns:p="http://schemas.openxmlformats.org/presentationml/2006/main">
+  <p:cSld>
+    <p:spTree>
+      <p:nvGrpSpPr>
+        <p:cNvPr id="1" name=""/>
+        <p:cNvGrpSpPr/>
+        <p:nvPr/>
+      </p:nvGrpSpPr>
+      <p:grpSpPr>
+        <a:xfrm>
+          <a:off x="0" y="0"/>
+          <a:ext cx="0" cy="0"/>
+          <a:chOff x="0" y="0"/>
+          <a:chExt cx="0" cy="0"/>
+        </a:xfrm>
+      </p:grpSpPr>
+      <p:pic>
+        <p:nvPicPr>
+          <p:cNvPr id="5" name="Picture 4">
+            <a:extLst>
+              <a:ext uri="{FF2B5EF4-FFF2-40B4-BE49-F238E27FC236}">
+                <a16:creationId xmlns:a16="http://schemas.microsoft.com/office/drawing/2014/main" id="{3553FA8F-4D01-0A7C-9619-9F479A778CF0}"/>
+              </a:ext>
+            </a:extLst>
+          </p:cNvPr>
+          <p:cNvPicPr>
+            <a:picLocks noChangeAspect="1"/>
+          </p:cNvPicPr>
+          <p:nvPr/>
+        </p:nvPicPr>
+        <p:blipFill>
+          <a:blip r:embed="rId2">
+            <a:extLst>
+              <a:ext uri="{28A0092B-C50C-407E-A947-70E740481C1C}">
+                <a14:useLocalDpi xmlns:a14="http://schemas.microsoft.com/office/drawing/2010/main" val="0"/>
+              </a:ext>
+            </a:extLst>
+          </a:blip>
+          <a:srcRect/>
+          <a:stretch/>
+        </p:blipFill>
+        <p:spPr>
+          <a:xfrm>
+            <a:off x="2667000" y="0"/>
+            <a:ext cx="6858000" cy="6858000"/>
+          </a:xfrm>
+          <a:prstGeom prst="rect">
+            <a:avLst/>
+          </a:prstGeom>
+        </p:spPr>
+      </p:pic>
+      <p:sp>
+        <p:nvSpPr>
+          <p:cNvPr id="6" name="Rectangle 5">
+            <a:extLst>
+              <a:ext uri="{FF2B5EF4-FFF2-40B4-BE49-F238E27FC236}">
+                <a16:creationId xmlns:a16="http://schemas.microsoft.com/office/drawing/2014/main" id="{59E1E98C-83FA-0164-022B-B4947BD73A17}"/>
+              </a:ext>
+            </a:extLst>
+          </p:cNvPr>
+          <p:cNvSpPr/>
+          <p:nvPr/>
+        </p:nvSpPr>
+        <p:spPr>
+          <a:xfrm>
+            <a:off x="5985163" y="519545"/>
+            <a:ext cx="405245" cy="6016337"/>
+          </a:xfrm>
+          <a:prstGeom prst="rect">
+            <a:avLst/>
+          </a:prstGeom>
+          <a:solidFill>
+            <a:schemeClr val="bg1"/>
+          </a:solidFill>
+          <a:ln>
+            <a:solidFill>
+              <a:schemeClr val="bg1"/>
+            </a:solidFill>
+          </a:ln>
+        </p:spPr>
+        <p:style>
+          <a:lnRef idx="2">
+            <a:schemeClr val="accent1">
+              <a:shade val="15000"/>
+            </a:schemeClr>
+          </a:lnRef>
+          <a:fillRef idx="1">
+            <a:schemeClr val="accent1"/>
+          </a:fillRef>
+          <a:effectRef idx="0">
+            <a:schemeClr val="accent1"/>
+          </a:effectRef>
+          <a:fontRef idx="minor">
+            <a:schemeClr val="lt1"/>
+          </a:fontRef>
+        </p:style>
+        <p:txBody>
+          <a:bodyPr rtlCol="0" anchor="ctr"/>
+          <a:lstStyle/>
+          <a:p>
+            <a:pPr algn="ctr"/>
+            <a:endParaRPr lang="en-US"/>
+          </a:p>
+        </p:txBody>
+      </p:sp>
+      <p:sp>
+        <p:nvSpPr>
+          <p:cNvPr id="8" name="Rectangle 7">
+            <a:extLst>
+              <a:ext uri="{FF2B5EF4-FFF2-40B4-BE49-F238E27FC236}">
+                <a16:creationId xmlns:a16="http://schemas.microsoft.com/office/drawing/2014/main" id="{EC2782E4-45B3-0C51-3289-0550DB3E08DE}"/>
+              </a:ext>
+            </a:extLst>
+          </p:cNvPr>
+          <p:cNvSpPr/>
+          <p:nvPr/>
+        </p:nvSpPr>
+        <p:spPr>
+          <a:xfrm>
+            <a:off x="2552700" y="114299"/>
+            <a:ext cx="405245" cy="2743201"/>
+          </a:xfrm>
+          <a:prstGeom prst="rect">
+            <a:avLst/>
+          </a:prstGeom>
+          <a:solidFill>
+            <a:schemeClr val="bg1"/>
+          </a:solidFill>
+          <a:ln>
+            <a:solidFill>
+              <a:schemeClr val="bg1"/>
+            </a:solidFill>
+          </a:ln>
+        </p:spPr>
+        <p:style>
+          <a:lnRef idx="2">
+            <a:schemeClr val="accent1">
+              <a:shade val="15000"/>
+            </a:schemeClr>
+          </a:lnRef>
+          <a:fillRef idx="1">
+            <a:schemeClr val="accent1"/>
+          </a:fillRef>
+          <a:effectRef idx="0">
+            <a:schemeClr val="accent1"/>
+          </a:effectRef>
+          <a:fontRef idx="minor">
+            <a:schemeClr val="lt1"/>
+          </a:fontRef>
+        </p:style>
+        <p:txBody>
+          <a:bodyPr rtlCol="0" anchor="ctr"/>
+          <a:lstStyle/>
+          <a:p>
+            <a:pPr algn="ctr"/>
+            <a:endParaRPr lang="en-US"/>
+          </a:p>
+        </p:txBody>
+      </p:sp>
+      <p:pic>
+        <p:nvPicPr>
+          <p:cNvPr id="10" name="Picture 9">
+            <a:extLst>
+              <a:ext uri="{FF2B5EF4-FFF2-40B4-BE49-F238E27FC236}">
+                <a16:creationId xmlns:a16="http://schemas.microsoft.com/office/drawing/2014/main" id="{8CC68211-BBF8-471D-DB60-9A59BD9C782E}"/>
+              </a:ext>
+            </a:extLst>
+          </p:cNvPr>
+          <p:cNvPicPr>
+            <a:picLocks noChangeAspect="1"/>
+          </p:cNvPicPr>
+          <p:nvPr/>
+        </p:nvPicPr>
+        <p:blipFill>
+          <a:blip r:embed="rId3">
+            <a:extLst>
+              <a:ext uri="{28A0092B-C50C-407E-A947-70E740481C1C}">
+                <a14:useLocalDpi xmlns:a14="http://schemas.microsoft.com/office/drawing/2010/main" val="0"/>
+              </a:ext>
+            </a:extLst>
+          </a:blip>
+          <a:srcRect l="454" t="58333" r="95354" b="11768"/>
+          <a:stretch>
+            <a:fillRect/>
+          </a:stretch>
+        </p:blipFill>
+        <p:spPr>
+          <a:xfrm>
+            <a:off x="2670461" y="519545"/>
+            <a:ext cx="287484" cy="2050473"/>
+          </a:xfrm>
+          <a:prstGeom prst="rect">
+            <a:avLst/>
+          </a:prstGeom>
+        </p:spPr>
+      </p:pic>
+    </p:spTree>
+    <p:extLst>
+      <p:ext uri="{BB962C8B-B14F-4D97-AF65-F5344CB8AC3E}">
+        <p14:creationId xmlns:p14="http://schemas.microsoft.com/office/powerpoint/2010/main" val="586023962"/>
+      </p:ext>
+    </p:extLst>
+  </p:cSld>
+  <p:clrMapOvr>
+    <a:masterClrMapping/>
+  </p:clrMapOvr>
+</p:sld>
+</file>
+
+<file path=ppt/slides/slide6.xml><?xml version="1.0" encoding="utf-8"?>
 <p:sld xmlns:a="http://schemas.openxmlformats.org/drawingml/2006/main" xmlns:r="http://schemas.openxmlformats.org/officeDocument/2006/relationships" xmlns:p="http://schemas.openxmlformats.org/presentationml/2006/main">
   <p:cSld>
     <p:spTree>
@@ -4426,12 +6081,18 @@
 </p:sld>
 </file>
 
-<file path=ppt/slides/slide3.xml><?xml version="1.0" encoding="utf-8"?>
+<file path=ppt/slides/slide7.xml><?xml version="1.0" encoding="utf-8"?>
 <p:sld xmlns:a="http://schemas.openxmlformats.org/drawingml/2006/main" xmlns:r="http://schemas.openxmlformats.org/officeDocument/2006/relationships" xmlns:p="http://schemas.openxmlformats.org/presentationml/2006/main">
   <p:cSld>
     <p:spTree>
       <p:nvGrpSpPr>
-        <p:cNvPr id="1" name=""/>
+        <p:cNvPr id="1" name="">
+          <a:extLst>
+            <a:ext uri="{FF2B5EF4-FFF2-40B4-BE49-F238E27FC236}">
+              <a16:creationId xmlns:a16="http://schemas.microsoft.com/office/drawing/2014/main" id="{4C03F464-9B07-23B3-99C4-6A25CADBB20A}"/>
+            </a:ext>
+          </a:extLst>
+        </p:cNvPr>
         <p:cNvGrpSpPr/>
         <p:nvPr/>
       </p:nvGrpSpPr>
@@ -4448,7 +6109,7 @@
           <p:cNvPr id="3" name="Picture 2">
             <a:extLst>
               <a:ext uri="{FF2B5EF4-FFF2-40B4-BE49-F238E27FC236}">
-                <a16:creationId xmlns:a16="http://schemas.microsoft.com/office/drawing/2014/main" id="{08152CBD-F19E-510F-E7EF-0A6D96CF03FD}"/>
+                <a16:creationId xmlns:a16="http://schemas.microsoft.com/office/drawing/2014/main" id="{B3CCE3D2-A3F1-3867-E3BC-31F2A9E85F0C}"/>
               </a:ext>
             </a:extLst>
           </p:cNvPr>
@@ -4465,9 +6126,8 @@
               </a:ext>
             </a:extLst>
           </a:blip>
-          <a:stretch>
-            <a:fillRect/>
-          </a:stretch>
+          <a:srcRect/>
+          <a:stretch/>
         </p:blipFill>
         <p:spPr>
           <a:xfrm>
@@ -4481,10 +6141,10 @@
       </p:pic>
       <p:pic>
         <p:nvPicPr>
-          <p:cNvPr id="5" name="Picture 4">
-            <a:extLst>
-              <a:ext uri="{FF2B5EF4-FFF2-40B4-BE49-F238E27FC236}">
-                <a16:creationId xmlns:a16="http://schemas.microsoft.com/office/drawing/2014/main" id="{D0F1B7D9-1001-6020-7E97-AE69E3F1A086}"/>
+          <p:cNvPr id="4" name="Picture 3">
+            <a:extLst>
+              <a:ext uri="{FF2B5EF4-FFF2-40B4-BE49-F238E27FC236}">
+                <a16:creationId xmlns:a16="http://schemas.microsoft.com/office/drawing/2014/main" id="{DA987469-563E-7132-4E4B-E0E6ADC04796}"/>
               </a:ext>
             </a:extLst>
           </p:cNvPr>
@@ -4519,10 +6179,10 @@
       </p:pic>
       <p:pic>
         <p:nvPicPr>
-          <p:cNvPr id="6" name="Picture 5">
-            <a:extLst>
-              <a:ext uri="{FF2B5EF4-FFF2-40B4-BE49-F238E27FC236}">
-                <a16:creationId xmlns:a16="http://schemas.microsoft.com/office/drawing/2014/main" id="{82159866-B503-EEE0-8A4C-942C7F4F80A4}"/>
+          <p:cNvPr id="5" name="Picture 4">
+            <a:extLst>
+              <a:ext uri="{FF2B5EF4-FFF2-40B4-BE49-F238E27FC236}">
+                <a16:creationId xmlns:a16="http://schemas.microsoft.com/office/drawing/2014/main" id="{35A8705A-1665-D8CB-C64D-DD06E401B43E}"/>
               </a:ext>
             </a:extLst>
           </p:cNvPr>
@@ -4558,149 +6218,7 @@
     </p:spTree>
     <p:extLst>
       <p:ext uri="{BB962C8B-B14F-4D97-AF65-F5344CB8AC3E}">
-        <p14:creationId xmlns:p14="http://schemas.microsoft.com/office/powerpoint/2010/main" val="1309627209"/>
-      </p:ext>
-    </p:extLst>
-  </p:cSld>
-  <p:clrMapOvr>
-    <a:masterClrMapping/>
-  </p:clrMapOvr>
-</p:sld>
-</file>
-
-<file path=ppt/slides/slide4.xml><?xml version="1.0" encoding="utf-8"?>
-<p:sld xmlns:a="http://schemas.openxmlformats.org/drawingml/2006/main" xmlns:r="http://schemas.openxmlformats.org/officeDocument/2006/relationships" xmlns:p="http://schemas.openxmlformats.org/presentationml/2006/main">
-  <p:cSld>
-    <p:spTree>
-      <p:nvGrpSpPr>
-        <p:cNvPr id="1" name=""/>
-        <p:cNvGrpSpPr/>
-        <p:nvPr/>
-      </p:nvGrpSpPr>
-      <p:grpSpPr>
-        <a:xfrm>
-          <a:off x="0" y="0"/>
-          <a:ext cx="0" cy="0"/>
-          <a:chOff x="0" y="0"/>
-          <a:chExt cx="0" cy="0"/>
-        </a:xfrm>
-      </p:grpSpPr>
-      <p:pic>
-        <p:nvPicPr>
-          <p:cNvPr id="3" name="Picture 2">
-            <a:extLst>
-              <a:ext uri="{FF2B5EF4-FFF2-40B4-BE49-F238E27FC236}">
-                <a16:creationId xmlns:a16="http://schemas.microsoft.com/office/drawing/2014/main" id="{9116910C-1E20-AE9D-D427-DD90CBEF6B96}"/>
-              </a:ext>
-            </a:extLst>
-          </p:cNvPr>
-          <p:cNvPicPr>
-            <a:picLocks noChangeAspect="1"/>
-          </p:cNvPicPr>
-          <p:nvPr/>
-        </p:nvPicPr>
-        <p:blipFill>
-          <a:blip r:embed="rId2">
-            <a:extLst>
-              <a:ext uri="{28A0092B-C50C-407E-A947-70E740481C1C}">
-                <a14:useLocalDpi xmlns:a14="http://schemas.microsoft.com/office/drawing/2010/main" val="0"/>
-              </a:ext>
-            </a:extLst>
-          </a:blip>
-          <a:stretch>
-            <a:fillRect/>
-          </a:stretch>
-        </p:blipFill>
-        <p:spPr>
-          <a:xfrm>
-            <a:off x="2238375" y="0"/>
-            <a:ext cx="7715250" cy="6858000"/>
-          </a:xfrm>
-          <a:prstGeom prst="rect">
-            <a:avLst/>
-          </a:prstGeom>
-        </p:spPr>
-      </p:pic>
-      <p:pic>
-        <p:nvPicPr>
-          <p:cNvPr id="4" name="Picture 3">
-            <a:extLst>
-              <a:ext uri="{FF2B5EF4-FFF2-40B4-BE49-F238E27FC236}">
-                <a16:creationId xmlns:a16="http://schemas.microsoft.com/office/drawing/2014/main" id="{39F4A8CE-85A2-035C-DEE3-8ECEB74F9E7D}"/>
-              </a:ext>
-            </a:extLst>
-          </p:cNvPr>
-          <p:cNvPicPr>
-            <a:picLocks noChangeAspect="1"/>
-          </p:cNvPicPr>
-          <p:nvPr/>
-        </p:nvPicPr>
-        <p:blipFill>
-          <a:blip r:embed="rId3">
-            <a:alphaModFix/>
-            <a:extLst>
-              <a:ext uri="{28A0092B-C50C-407E-A947-70E740481C1C}">
-                <a14:useLocalDpi xmlns:a14="http://schemas.microsoft.com/office/drawing/2010/main" val="0"/>
-              </a:ext>
-            </a:extLst>
-          </a:blip>
-          <a:srcRect l="37689" t="27752" r="52940" b="20620"/>
-          <a:stretch>
-            <a:fillRect/>
-          </a:stretch>
-        </p:blipFill>
-        <p:spPr>
-          <a:xfrm>
-            <a:off x="9263529" y="5014128"/>
-            <a:ext cx="151776" cy="381378"/>
-          </a:xfrm>
-          <a:prstGeom prst="rect">
-            <a:avLst/>
-          </a:prstGeom>
-        </p:spPr>
-      </p:pic>
-      <p:pic>
-        <p:nvPicPr>
-          <p:cNvPr id="5" name="Picture 4">
-            <a:extLst>
-              <a:ext uri="{FF2B5EF4-FFF2-40B4-BE49-F238E27FC236}">
-                <a16:creationId xmlns:a16="http://schemas.microsoft.com/office/drawing/2014/main" id="{D76F768C-C137-FE89-E3D8-649B558235F7}"/>
-              </a:ext>
-            </a:extLst>
-          </p:cNvPr>
-          <p:cNvPicPr>
-            <a:picLocks noChangeAspect="1"/>
-          </p:cNvPicPr>
-          <p:nvPr/>
-        </p:nvPicPr>
-        <p:blipFill>
-          <a:blip r:embed="rId3">
-            <a:alphaModFix/>
-            <a:extLst>
-              <a:ext uri="{28A0092B-C50C-407E-A947-70E740481C1C}">
-                <a14:useLocalDpi xmlns:a14="http://schemas.microsoft.com/office/drawing/2010/main" val="0"/>
-              </a:ext>
-            </a:extLst>
-          </a:blip>
-          <a:srcRect l="37689" t="27752" r="52940" b="20620"/>
-          <a:stretch>
-            <a:fillRect/>
-          </a:stretch>
-        </p:blipFill>
-        <p:spPr>
-          <a:xfrm>
-            <a:off x="9263529" y="1584275"/>
-            <a:ext cx="151776" cy="381378"/>
-          </a:xfrm>
-          <a:prstGeom prst="rect">
-            <a:avLst/>
-          </a:prstGeom>
-        </p:spPr>
-      </p:pic>
-    </p:spTree>
-    <p:extLst>
-      <p:ext uri="{BB962C8B-B14F-4D97-AF65-F5344CB8AC3E}">
-        <p14:creationId xmlns:p14="http://schemas.microsoft.com/office/powerpoint/2010/main" val="2868907441"/>
+        <p14:creationId xmlns:p14="http://schemas.microsoft.com/office/powerpoint/2010/main" val="4102444512"/>
       </p:ext>
     </p:extLst>
   </p:cSld>

</xml_diff>

<commit_message>
ch1 figures fin for now
</commit_message>
<xml_diff>
--- a/figures/ch1/ch1_figures.pptx
+++ b/figures/ch1/ch1_figures.pptx
@@ -10,8 +10,9 @@
     <p:sldId id="267" r:id="rId4"/>
     <p:sldId id="266" r:id="rId5"/>
     <p:sldId id="268" r:id="rId6"/>
-    <p:sldId id="261" r:id="rId7"/>
-    <p:sldId id="262" r:id="rId8"/>
+    <p:sldId id="269" r:id="rId7"/>
+    <p:sldId id="261" r:id="rId8"/>
+    <p:sldId id="262" r:id="rId9"/>
   </p:sldIdLst>
   <p:sldSz cx="12192000" cy="6858000"/>
   <p:notesSz cx="6858000" cy="9144000"/>
@@ -265,7 +266,7 @@
           <a:p>
             <a:fld id="{6AECCEE4-E404-41DF-89A3-E64313283A40}" type="datetimeFigureOut">
               <a:rPr lang="en-US" smtClean="0"/>
-              <a:t>7/6/2026</a:t>
+              <a:t>7/7/2026</a:t>
             </a:fld>
             <a:endParaRPr lang="en-US"/>
           </a:p>
@@ -463,7 +464,7 @@
           <a:p>
             <a:fld id="{6AECCEE4-E404-41DF-89A3-E64313283A40}" type="datetimeFigureOut">
               <a:rPr lang="en-US" smtClean="0"/>
-              <a:t>7/6/2026</a:t>
+              <a:t>7/7/2026</a:t>
             </a:fld>
             <a:endParaRPr lang="en-US"/>
           </a:p>
@@ -671,7 +672,7 @@
           <a:p>
             <a:fld id="{6AECCEE4-E404-41DF-89A3-E64313283A40}" type="datetimeFigureOut">
               <a:rPr lang="en-US" smtClean="0"/>
-              <a:t>7/6/2026</a:t>
+              <a:t>7/7/2026</a:t>
             </a:fld>
             <a:endParaRPr lang="en-US"/>
           </a:p>
@@ -869,7 +870,7 @@
           <a:p>
             <a:fld id="{6AECCEE4-E404-41DF-89A3-E64313283A40}" type="datetimeFigureOut">
               <a:rPr lang="en-US" smtClean="0"/>
-              <a:t>7/6/2026</a:t>
+              <a:t>7/7/2026</a:t>
             </a:fld>
             <a:endParaRPr lang="en-US"/>
           </a:p>
@@ -1144,7 +1145,7 @@
           <a:p>
             <a:fld id="{6AECCEE4-E404-41DF-89A3-E64313283A40}" type="datetimeFigureOut">
               <a:rPr lang="en-US" smtClean="0"/>
-              <a:t>7/6/2026</a:t>
+              <a:t>7/7/2026</a:t>
             </a:fld>
             <a:endParaRPr lang="en-US"/>
           </a:p>
@@ -1409,7 +1410,7 @@
           <a:p>
             <a:fld id="{6AECCEE4-E404-41DF-89A3-E64313283A40}" type="datetimeFigureOut">
               <a:rPr lang="en-US" smtClean="0"/>
-              <a:t>7/6/2026</a:t>
+              <a:t>7/7/2026</a:t>
             </a:fld>
             <a:endParaRPr lang="en-US"/>
           </a:p>
@@ -1821,7 +1822,7 @@
           <a:p>
             <a:fld id="{6AECCEE4-E404-41DF-89A3-E64313283A40}" type="datetimeFigureOut">
               <a:rPr lang="en-US" smtClean="0"/>
-              <a:t>7/6/2026</a:t>
+              <a:t>7/7/2026</a:t>
             </a:fld>
             <a:endParaRPr lang="en-US"/>
           </a:p>
@@ -1962,7 +1963,7 @@
           <a:p>
             <a:fld id="{6AECCEE4-E404-41DF-89A3-E64313283A40}" type="datetimeFigureOut">
               <a:rPr lang="en-US" smtClean="0"/>
-              <a:t>7/6/2026</a:t>
+              <a:t>7/7/2026</a:t>
             </a:fld>
             <a:endParaRPr lang="en-US"/>
           </a:p>
@@ -2075,7 +2076,7 @@
           <a:p>
             <a:fld id="{6AECCEE4-E404-41DF-89A3-E64313283A40}" type="datetimeFigureOut">
               <a:rPr lang="en-US" smtClean="0"/>
-              <a:t>7/6/2026</a:t>
+              <a:t>7/7/2026</a:t>
             </a:fld>
             <a:endParaRPr lang="en-US"/>
           </a:p>
@@ -2386,7 +2387,7 @@
           <a:p>
             <a:fld id="{6AECCEE4-E404-41DF-89A3-E64313283A40}" type="datetimeFigureOut">
               <a:rPr lang="en-US" smtClean="0"/>
-              <a:t>7/6/2026</a:t>
+              <a:t>7/7/2026</a:t>
             </a:fld>
             <a:endParaRPr lang="en-US"/>
           </a:p>
@@ -2674,7 +2675,7 @@
           <a:p>
             <a:fld id="{6AECCEE4-E404-41DF-89A3-E64313283A40}" type="datetimeFigureOut">
               <a:rPr lang="en-US" smtClean="0"/>
-              <a:t>7/6/2026</a:t>
+              <a:t>7/7/2026</a:t>
             </a:fld>
             <a:endParaRPr lang="en-US"/>
           </a:p>
@@ -2915,7 +2916,7 @@
           <a:p>
             <a:fld id="{6AECCEE4-E404-41DF-89A3-E64313283A40}" type="datetimeFigureOut">
               <a:rPr lang="en-US" smtClean="0"/>
-              <a:t>7/6/2026</a:t>
+              <a:t>7/7/2026</a:t>
             </a:fld>
             <a:endParaRPr lang="en-US"/>
           </a:p>
@@ -4449,6 +4450,53 @@
           </a:prstGeom>
         </p:spPr>
       </p:pic>
+      <p:sp>
+        <p:nvSpPr>
+          <p:cNvPr id="3" name="TextBox 2">
+            <a:extLst>
+              <a:ext uri="{FF2B5EF4-FFF2-40B4-BE49-F238E27FC236}">
+                <a16:creationId xmlns:a16="http://schemas.microsoft.com/office/drawing/2014/main" id="{4114E72C-64DC-DFBB-78E4-6F5EE401CE8A}"/>
+              </a:ext>
+            </a:extLst>
+          </p:cNvPr>
+          <p:cNvSpPr txBox="1"/>
+          <p:nvPr/>
+        </p:nvSpPr>
+        <p:spPr>
+          <a:xfrm>
+            <a:off x="114300" y="228600"/>
+            <a:ext cx="1070264" cy="923330"/>
+          </a:xfrm>
+          <a:prstGeom prst="rect">
+            <a:avLst/>
+          </a:prstGeom>
+          <a:noFill/>
+        </p:spPr>
+        <p:txBody>
+          <a:bodyPr wrap="square" rtlCol="0">
+            <a:spAutoFit/>
+          </a:bodyPr>
+          <a:lstStyle/>
+          <a:p>
+            <a:r>
+              <a:rPr lang="en-US" dirty="0"/>
+              <a:t>F3</a:t>
+            </a:r>
+          </a:p>
+          <a:p>
+            <a:r>
+              <a:rPr lang="en-US" dirty="0"/>
+              <a:t>All</a:t>
+            </a:r>
+          </a:p>
+          <a:p>
+            <a:r>
+              <a:rPr lang="en-US" dirty="0"/>
+              <a:t>Black</a:t>
+            </a:r>
+          </a:p>
+        </p:txBody>
+      </p:sp>
     </p:spTree>
     <p:extLst>
       <p:ext uri="{BB962C8B-B14F-4D97-AF65-F5344CB8AC3E}">
@@ -5079,6 +5127,47 @@
           </a:prstGeom>
         </p:spPr>
       </p:pic>
+      <p:sp>
+        <p:nvSpPr>
+          <p:cNvPr id="4" name="TextBox 3">
+            <a:extLst>
+              <a:ext uri="{FF2B5EF4-FFF2-40B4-BE49-F238E27FC236}">
+                <a16:creationId xmlns:a16="http://schemas.microsoft.com/office/drawing/2014/main" id="{274DAD51-509E-F308-6F1B-819DFEBD3BA1}"/>
+              </a:ext>
+            </a:extLst>
+          </p:cNvPr>
+          <p:cNvSpPr txBox="1"/>
+          <p:nvPr/>
+        </p:nvSpPr>
+        <p:spPr>
+          <a:xfrm>
+            <a:off x="114300" y="228600"/>
+            <a:ext cx="1070264" cy="923330"/>
+          </a:xfrm>
+          <a:prstGeom prst="rect">
+            <a:avLst/>
+          </a:prstGeom>
+          <a:noFill/>
+        </p:spPr>
+        <p:txBody>
+          <a:bodyPr wrap="square" rtlCol="0">
+            <a:spAutoFit/>
+          </a:bodyPr>
+          <a:lstStyle/>
+          <a:p>
+            <a:r>
+              <a:rPr lang="en-US" dirty="0"/>
+              <a:t>F3</a:t>
+            </a:r>
+          </a:p>
+          <a:p>
+            <a:r>
+              <a:rPr lang="en-US" dirty="0"/>
+              <a:t>Partial Color</a:t>
+            </a:r>
+          </a:p>
+        </p:txBody>
+      </p:sp>
     </p:spTree>
     <p:extLst>
       <p:ext uri="{BB962C8B-B14F-4D97-AF65-F5344CB8AC3E}">
@@ -5711,6 +5800,53 @@
           </a:prstGeom>
         </p:spPr>
       </p:pic>
+      <p:sp>
+        <p:nvSpPr>
+          <p:cNvPr id="7" name="TextBox 6">
+            <a:extLst>
+              <a:ext uri="{FF2B5EF4-FFF2-40B4-BE49-F238E27FC236}">
+                <a16:creationId xmlns:a16="http://schemas.microsoft.com/office/drawing/2014/main" id="{7BC848CB-EB9E-E785-BD4C-8B01642F13A3}"/>
+              </a:ext>
+            </a:extLst>
+          </p:cNvPr>
+          <p:cNvSpPr txBox="1"/>
+          <p:nvPr/>
+        </p:nvSpPr>
+        <p:spPr>
+          <a:xfrm>
+            <a:off x="114300" y="228600"/>
+            <a:ext cx="4244866" cy="923330"/>
+          </a:xfrm>
+          <a:prstGeom prst="rect">
+            <a:avLst/>
+          </a:prstGeom>
+          <a:noFill/>
+        </p:spPr>
+        <p:txBody>
+          <a:bodyPr wrap="square" rtlCol="0">
+            <a:spAutoFit/>
+          </a:bodyPr>
+          <a:lstStyle/>
+          <a:p>
+            <a:r>
+              <a:rPr lang="en-US" dirty="0"/>
+              <a:t>F3</a:t>
+            </a:r>
+          </a:p>
+          <a:p>
+            <a:r>
+              <a:rPr lang="en-US" dirty="0"/>
+              <a:t>All</a:t>
+            </a:r>
+          </a:p>
+          <a:p>
+            <a:r>
+              <a:rPr lang="en-US" dirty="0"/>
+              <a:t>Color (this one isn’t as good imo)</a:t>
+            </a:r>
+          </a:p>
+        </p:txBody>
+      </p:sp>
     </p:spTree>
     <p:extLst>
       <p:ext uri="{BB962C8B-B14F-4D97-AF65-F5344CB8AC3E}">
@@ -5751,7 +5887,7 @@
             </a:extLst>
           </p:cNvPr>
           <p:cNvPicPr>
-            <a:picLocks noChangeAspect="1"/>
+            <a:picLocks noGrp="1" noRot="1" noChangeAspect="1" noMove="1" noResize="1" noEditPoints="1" noAdjustHandles="1" noChangeArrowheads="1" noChangeShapeType="1" noCrop="1"/>
           </p:cNvPicPr>
           <p:nvPr/>
         </p:nvPicPr>
@@ -5785,7 +5921,9 @@
               </a:ext>
             </a:extLst>
           </p:cNvPr>
-          <p:cNvSpPr/>
+          <p:cNvSpPr>
+            <a:spLocks noGrp="1" noRot="1" noMove="1" noResize="1" noEditPoints="1" noAdjustHandles="1" noChangeArrowheads="1" noChangeShapeType="1"/>
+          </p:cNvSpPr>
           <p:nvPr/>
         </p:nvSpPr>
         <p:spPr>
@@ -5921,6 +6059,443 @@
           </a:prstGeom>
         </p:spPr>
       </p:pic>
+      <p:sp>
+        <p:nvSpPr>
+          <p:cNvPr id="2" name="TextBox 1">
+            <a:extLst>
+              <a:ext uri="{FF2B5EF4-FFF2-40B4-BE49-F238E27FC236}">
+                <a16:creationId xmlns:a16="http://schemas.microsoft.com/office/drawing/2014/main" id="{B1F9DEF5-F28D-767F-46FD-DBDEDBAA780A}"/>
+              </a:ext>
+            </a:extLst>
+          </p:cNvPr>
+          <p:cNvSpPr txBox="1"/>
+          <p:nvPr/>
+        </p:nvSpPr>
+        <p:spPr>
+          <a:xfrm>
+            <a:off x="114300" y="228600"/>
+            <a:ext cx="1070264" cy="1477328"/>
+          </a:xfrm>
+          <a:prstGeom prst="rect">
+            <a:avLst/>
+          </a:prstGeom>
+          <a:noFill/>
+        </p:spPr>
+        <p:txBody>
+          <a:bodyPr wrap="square" rtlCol="0">
+            <a:spAutoFit/>
+          </a:bodyPr>
+          <a:lstStyle/>
+          <a:p>
+            <a:r>
+              <a:rPr lang="en-US" dirty="0"/>
+              <a:t>SF1</a:t>
+            </a:r>
+          </a:p>
+          <a:p>
+            <a:r>
+              <a:rPr lang="en-US" dirty="0"/>
+              <a:t>Show Scaled Regional Trend</a:t>
+            </a:r>
+          </a:p>
+        </p:txBody>
+      </p:sp>
+      <p:pic>
+        <p:nvPicPr>
+          <p:cNvPr id="4" name="Graphic 3" descr="Thermometer with solid fill">
+            <a:extLst>
+              <a:ext uri="{FF2B5EF4-FFF2-40B4-BE49-F238E27FC236}">
+                <a16:creationId xmlns:a16="http://schemas.microsoft.com/office/drawing/2014/main" id="{E6E10C15-6B1C-D622-EE17-28826542DEE7}"/>
+              </a:ext>
+            </a:extLst>
+          </p:cNvPr>
+          <p:cNvPicPr>
+            <a:picLocks noChangeAspect="1"/>
+          </p:cNvPicPr>
+          <p:nvPr/>
+        </p:nvPicPr>
+        <p:blipFill>
+          <a:blip>
+            <a:extLst>
+              <a:ext uri="{96DAC541-7B7A-43D3-8B79-37D633B846F1}">
+                <asvg:svgBlip xmlns:asvg="http://schemas.microsoft.com/office/drawing/2016/SVG/main" r:embed="rId4"/>
+              </a:ext>
+            </a:extLst>
+          </a:blip>
+          <a:stretch>
+            <a:fillRect/>
+          </a:stretch>
+        </p:blipFill>
+        <p:spPr>
+          <a:xfrm>
+            <a:off x="3383608" y="2517613"/>
+            <a:ext cx="357671" cy="357671"/>
+          </a:xfrm>
+          <a:prstGeom prst="rect">
+            <a:avLst/>
+          </a:prstGeom>
+        </p:spPr>
+      </p:pic>
+      <p:pic>
+        <p:nvPicPr>
+          <p:cNvPr id="9" name="Graphic 8" descr="Thermometer with solid fill">
+            <a:extLst>
+              <a:ext uri="{FF2B5EF4-FFF2-40B4-BE49-F238E27FC236}">
+                <a16:creationId xmlns:a16="http://schemas.microsoft.com/office/drawing/2014/main" id="{EF2B4B10-4A9E-1010-A960-375B09C4CED1}"/>
+              </a:ext>
+            </a:extLst>
+          </p:cNvPr>
+          <p:cNvPicPr>
+            <a:picLocks noChangeAspect="1"/>
+          </p:cNvPicPr>
+          <p:nvPr/>
+        </p:nvPicPr>
+        <p:blipFill>
+          <a:blip>
+            <a:extLst>
+              <a:ext uri="{96DAC541-7B7A-43D3-8B79-37D633B846F1}">
+                <asvg:svgBlip xmlns:asvg="http://schemas.microsoft.com/office/drawing/2016/SVG/main" r:embed="rId4"/>
+              </a:ext>
+            </a:extLst>
+          </a:blip>
+          <a:stretch>
+            <a:fillRect/>
+          </a:stretch>
+        </p:blipFill>
+        <p:spPr>
+          <a:xfrm>
+            <a:off x="5292778" y="2517613"/>
+            <a:ext cx="357671" cy="357671"/>
+          </a:xfrm>
+          <a:prstGeom prst="rect">
+            <a:avLst/>
+          </a:prstGeom>
+        </p:spPr>
+      </p:pic>
+      <p:pic>
+        <p:nvPicPr>
+          <p:cNvPr id="12" name="Graphic 11" descr="Snowflake with solid fill">
+            <a:extLst>
+              <a:ext uri="{FF2B5EF4-FFF2-40B4-BE49-F238E27FC236}">
+                <a16:creationId xmlns:a16="http://schemas.microsoft.com/office/drawing/2014/main" id="{F463658C-D7C9-F546-80B9-25F336D56792}"/>
+              </a:ext>
+            </a:extLst>
+          </p:cNvPr>
+          <p:cNvPicPr>
+            <a:picLocks noChangeAspect="1"/>
+          </p:cNvPicPr>
+          <p:nvPr/>
+        </p:nvPicPr>
+        <p:blipFill>
+          <a:blip>
+            <a:extLst>
+              <a:ext uri="{96DAC541-7B7A-43D3-8B79-37D633B846F1}">
+                <asvg:svgBlip xmlns:asvg="http://schemas.microsoft.com/office/drawing/2016/SVG/main" r:embed="rId5"/>
+              </a:ext>
+            </a:extLst>
+          </a:blip>
+          <a:stretch>
+            <a:fillRect/>
+          </a:stretch>
+        </p:blipFill>
+        <p:spPr>
+          <a:xfrm>
+            <a:off x="3609843" y="2393198"/>
+            <a:ext cx="402081" cy="402081"/>
+          </a:xfrm>
+          <a:prstGeom prst="rect">
+            <a:avLst/>
+          </a:prstGeom>
+        </p:spPr>
+      </p:pic>
+      <p:pic>
+        <p:nvPicPr>
+          <p:cNvPr id="14" name="Graphic 13" descr="Fire with solid fill">
+            <a:extLst>
+              <a:ext uri="{FF2B5EF4-FFF2-40B4-BE49-F238E27FC236}">
+                <a16:creationId xmlns:a16="http://schemas.microsoft.com/office/drawing/2014/main" id="{E7460522-C5EF-B4E4-CAFE-3740B96383A0}"/>
+              </a:ext>
+            </a:extLst>
+          </p:cNvPr>
+          <p:cNvPicPr>
+            <a:picLocks noChangeAspect="1"/>
+          </p:cNvPicPr>
+          <p:nvPr/>
+        </p:nvPicPr>
+        <p:blipFill>
+          <a:blip>
+            <a:extLst>
+              <a:ext uri="{96DAC541-7B7A-43D3-8B79-37D633B846F1}">
+                <asvg:svgBlip xmlns:asvg="http://schemas.microsoft.com/office/drawing/2016/SVG/main" r:embed="rId6"/>
+              </a:ext>
+            </a:extLst>
+          </a:blip>
+          <a:stretch>
+            <a:fillRect/>
+          </a:stretch>
+        </p:blipFill>
+        <p:spPr>
+          <a:xfrm>
+            <a:off x="5523611" y="2333619"/>
+            <a:ext cx="357671" cy="357671"/>
+          </a:xfrm>
+          <a:prstGeom prst="rect">
+            <a:avLst/>
+          </a:prstGeom>
+        </p:spPr>
+      </p:pic>
+      <p:pic>
+        <p:nvPicPr>
+          <p:cNvPr id="18" name="Graphic 17" descr="Forest scene with solid fill">
+            <a:extLst>
+              <a:ext uri="{FF2B5EF4-FFF2-40B4-BE49-F238E27FC236}">
+                <a16:creationId xmlns:a16="http://schemas.microsoft.com/office/drawing/2014/main" id="{A3395A0A-A125-2DF0-437B-51431F1C5008}"/>
+              </a:ext>
+            </a:extLst>
+          </p:cNvPr>
+          <p:cNvPicPr>
+            <a:picLocks noChangeAspect="1"/>
+          </p:cNvPicPr>
+          <p:nvPr/>
+        </p:nvPicPr>
+        <p:blipFill>
+          <a:blip>
+            <a:extLst>
+              <a:ext uri="{96DAC541-7B7A-43D3-8B79-37D633B846F1}">
+                <asvg:svgBlip xmlns:asvg="http://schemas.microsoft.com/office/drawing/2016/SVG/main" r:embed="rId7"/>
+              </a:ext>
+            </a:extLst>
+          </a:blip>
+          <a:stretch>
+            <a:fillRect/>
+          </a:stretch>
+        </p:blipFill>
+        <p:spPr>
+          <a:xfrm>
+            <a:off x="8700855" y="2323998"/>
+            <a:ext cx="582886" cy="582886"/>
+          </a:xfrm>
+          <a:prstGeom prst="rect">
+            <a:avLst/>
+          </a:prstGeom>
+        </p:spPr>
+      </p:pic>
+      <p:pic>
+        <p:nvPicPr>
+          <p:cNvPr id="20" name="Graphic 19" descr="Forest scene with solid fill">
+            <a:extLst>
+              <a:ext uri="{FF2B5EF4-FFF2-40B4-BE49-F238E27FC236}">
+                <a16:creationId xmlns:a16="http://schemas.microsoft.com/office/drawing/2014/main" id="{E29A7E9A-4B07-E26C-3558-B6EEE5F30496}"/>
+              </a:ext>
+            </a:extLst>
+          </p:cNvPr>
+          <p:cNvPicPr>
+            <a:picLocks noChangeAspect="1"/>
+          </p:cNvPicPr>
+          <p:nvPr/>
+        </p:nvPicPr>
+        <p:blipFill>
+          <a:blip>
+            <a:extLst>
+              <a:ext uri="{96DAC541-7B7A-43D3-8B79-37D633B846F1}">
+                <asvg:svgBlip xmlns:asvg="http://schemas.microsoft.com/office/drawing/2016/SVG/main" r:embed="rId7"/>
+              </a:ext>
+            </a:extLst>
+          </a:blip>
+          <a:stretch>
+            <a:fillRect/>
+          </a:stretch>
+        </p:blipFill>
+        <p:spPr>
+          <a:xfrm>
+            <a:off x="6881540" y="2571246"/>
+            <a:ext cx="308564" cy="308564"/>
+          </a:xfrm>
+          <a:prstGeom prst="rect">
+            <a:avLst/>
+          </a:prstGeom>
+        </p:spPr>
+      </p:pic>
+      <p:pic>
+        <p:nvPicPr>
+          <p:cNvPr id="22" name="Graphic 21" descr="Crops with solid fill">
+            <a:extLst>
+              <a:ext uri="{FF2B5EF4-FFF2-40B4-BE49-F238E27FC236}">
+                <a16:creationId xmlns:a16="http://schemas.microsoft.com/office/drawing/2014/main" id="{E326474E-DB66-F318-5987-3418F198846C}"/>
+              </a:ext>
+            </a:extLst>
+          </p:cNvPr>
+          <p:cNvPicPr>
+            <a:picLocks noChangeAspect="1"/>
+          </p:cNvPicPr>
+          <p:nvPr/>
+        </p:nvPicPr>
+        <p:blipFill>
+          <a:blip>
+            <a:extLst>
+              <a:ext uri="{96DAC541-7B7A-43D3-8B79-37D633B846F1}">
+                <asvg:svgBlip xmlns:asvg="http://schemas.microsoft.com/office/drawing/2016/SVG/main" r:embed="rId8"/>
+              </a:ext>
+            </a:extLst>
+          </a:blip>
+          <a:stretch>
+            <a:fillRect/>
+          </a:stretch>
+        </p:blipFill>
+        <p:spPr>
+          <a:xfrm>
+            <a:off x="7201948" y="2565090"/>
+            <a:ext cx="310193" cy="310193"/>
+          </a:xfrm>
+          <a:prstGeom prst="rect">
+            <a:avLst/>
+          </a:prstGeom>
+        </p:spPr>
+      </p:pic>
+      <p:pic>
+        <p:nvPicPr>
+          <p:cNvPr id="24" name="Graphic 23" descr="City with solid fill">
+            <a:extLst>
+              <a:ext uri="{FF2B5EF4-FFF2-40B4-BE49-F238E27FC236}">
+                <a16:creationId xmlns:a16="http://schemas.microsoft.com/office/drawing/2014/main" id="{4435FF93-04EA-7FEF-8320-C75D6B30128D}"/>
+              </a:ext>
+            </a:extLst>
+          </p:cNvPr>
+          <p:cNvPicPr>
+            <a:picLocks noChangeAspect="1"/>
+          </p:cNvPicPr>
+          <p:nvPr/>
+        </p:nvPicPr>
+        <p:blipFill>
+          <a:blip>
+            <a:extLst>
+              <a:ext uri="{96DAC541-7B7A-43D3-8B79-37D633B846F1}">
+                <asvg:svgBlip xmlns:asvg="http://schemas.microsoft.com/office/drawing/2016/SVG/main" r:embed="rId9"/>
+              </a:ext>
+            </a:extLst>
+          </a:blip>
+          <a:stretch>
+            <a:fillRect/>
+          </a:stretch>
+        </p:blipFill>
+        <p:spPr>
+          <a:xfrm>
+            <a:off x="6871332" y="2317465"/>
+            <a:ext cx="310193" cy="310193"/>
+          </a:xfrm>
+          <a:prstGeom prst="rect">
+            <a:avLst/>
+          </a:prstGeom>
+        </p:spPr>
+      </p:pic>
+      <p:pic>
+        <p:nvPicPr>
+          <p:cNvPr id="26" name="Graphic 25" descr="Rainforest with solid fill">
+            <a:extLst>
+              <a:ext uri="{FF2B5EF4-FFF2-40B4-BE49-F238E27FC236}">
+                <a16:creationId xmlns:a16="http://schemas.microsoft.com/office/drawing/2014/main" id="{B9DB83BA-4270-9ED6-D151-A1D136C7AD46}"/>
+              </a:ext>
+            </a:extLst>
+          </p:cNvPr>
+          <p:cNvPicPr>
+            <a:picLocks noChangeAspect="1"/>
+          </p:cNvPicPr>
+          <p:nvPr/>
+        </p:nvPicPr>
+        <p:blipFill>
+          <a:blip>
+            <a:extLst>
+              <a:ext uri="{96DAC541-7B7A-43D3-8B79-37D633B846F1}">
+                <asvg:svgBlip xmlns:asvg="http://schemas.microsoft.com/office/drawing/2016/SVG/main" r:embed="rId10"/>
+              </a:ext>
+            </a:extLst>
+          </a:blip>
+          <a:stretch>
+            <a:fillRect/>
+          </a:stretch>
+        </p:blipFill>
+        <p:spPr>
+          <a:xfrm>
+            <a:off x="7218800" y="2323997"/>
+            <a:ext cx="268767" cy="268767"/>
+          </a:xfrm>
+          <a:prstGeom prst="rect">
+            <a:avLst/>
+          </a:prstGeom>
+        </p:spPr>
+      </p:pic>
+      <p:pic>
+        <p:nvPicPr>
+          <p:cNvPr id="28" name="Graphic 27" descr="Caterpillar with solid fill">
+            <a:extLst>
+              <a:ext uri="{FF2B5EF4-FFF2-40B4-BE49-F238E27FC236}">
+                <a16:creationId xmlns:a16="http://schemas.microsoft.com/office/drawing/2014/main" id="{4F5DBFC1-705F-7EDE-A650-2F34B52D60FC}"/>
+              </a:ext>
+            </a:extLst>
+          </p:cNvPr>
+          <p:cNvPicPr>
+            <a:picLocks noChangeAspect="1"/>
+          </p:cNvPicPr>
+          <p:nvPr/>
+        </p:nvPicPr>
+        <p:blipFill>
+          <a:blip>
+            <a:extLst>
+              <a:ext uri="{96DAC541-7B7A-43D3-8B79-37D633B846F1}">
+                <asvg:svgBlip xmlns:asvg="http://schemas.microsoft.com/office/drawing/2016/SVG/main" r:embed="rId11"/>
+              </a:ext>
+            </a:extLst>
+          </a:blip>
+          <a:stretch>
+            <a:fillRect/>
+          </a:stretch>
+        </p:blipFill>
+        <p:spPr>
+          <a:xfrm>
+            <a:off x="5447826" y="5909303"/>
+            <a:ext cx="405245" cy="405245"/>
+          </a:xfrm>
+          <a:prstGeom prst="rect">
+            <a:avLst/>
+          </a:prstGeom>
+        </p:spPr>
+      </p:pic>
+      <p:pic>
+        <p:nvPicPr>
+          <p:cNvPr id="30" name="Graphic 29" descr="Blueberry with solid fill">
+            <a:extLst>
+              <a:ext uri="{FF2B5EF4-FFF2-40B4-BE49-F238E27FC236}">
+                <a16:creationId xmlns:a16="http://schemas.microsoft.com/office/drawing/2014/main" id="{1B30F1F0-5332-3681-5B6D-AAF90D08FBEE}"/>
+              </a:ext>
+            </a:extLst>
+          </p:cNvPr>
+          <p:cNvPicPr>
+            <a:picLocks noChangeAspect="1"/>
+          </p:cNvPicPr>
+          <p:nvPr/>
+        </p:nvPicPr>
+        <p:blipFill>
+          <a:blip>
+            <a:extLst>
+              <a:ext uri="{96DAC541-7B7A-43D3-8B79-37D633B846F1}">
+                <asvg:svgBlip xmlns:asvg="http://schemas.microsoft.com/office/drawing/2016/SVG/main" r:embed="rId12"/>
+              </a:ext>
+            </a:extLst>
+          </a:blip>
+          <a:stretch>
+            <a:fillRect/>
+          </a:stretch>
+        </p:blipFill>
+        <p:spPr>
+          <a:xfrm>
+            <a:off x="3383608" y="5961077"/>
+            <a:ext cx="353471" cy="353471"/>
+          </a:xfrm>
+          <a:prstGeom prst="rect">
+            <a:avLst/>
+          </a:prstGeom>
+        </p:spPr>
+      </p:pic>
     </p:spTree>
     <p:extLst>
       <p:ext uri="{BB962C8B-B14F-4D97-AF65-F5344CB8AC3E}">
@@ -5935,6 +6510,275 @@
 </file>
 
 <file path=ppt/slides/slide6.xml><?xml version="1.0" encoding="utf-8"?>
+<p:sld xmlns:a="http://schemas.openxmlformats.org/drawingml/2006/main" xmlns:r="http://schemas.openxmlformats.org/officeDocument/2006/relationships" xmlns:p="http://schemas.openxmlformats.org/presentationml/2006/main">
+  <p:cSld>
+    <p:spTree>
+      <p:nvGrpSpPr>
+        <p:cNvPr id="1" name="">
+          <a:extLst>
+            <a:ext uri="{FF2B5EF4-FFF2-40B4-BE49-F238E27FC236}">
+              <a16:creationId xmlns:a16="http://schemas.microsoft.com/office/drawing/2014/main" id="{F1311D80-9C35-3F9E-5E06-2C18B64E4A9A}"/>
+            </a:ext>
+          </a:extLst>
+        </p:cNvPr>
+        <p:cNvGrpSpPr/>
+        <p:nvPr/>
+      </p:nvGrpSpPr>
+      <p:grpSpPr>
+        <a:xfrm>
+          <a:off x="0" y="0"/>
+          <a:ext cx="0" cy="0"/>
+          <a:chOff x="0" y="0"/>
+          <a:chExt cx="0" cy="0"/>
+        </a:xfrm>
+      </p:grpSpPr>
+      <p:pic>
+        <p:nvPicPr>
+          <p:cNvPr id="5" name="Picture 4">
+            <a:extLst>
+              <a:ext uri="{FF2B5EF4-FFF2-40B4-BE49-F238E27FC236}">
+                <a16:creationId xmlns:a16="http://schemas.microsoft.com/office/drawing/2014/main" id="{98EA18C7-8481-368A-BC8E-4EAC020B900A}"/>
+              </a:ext>
+            </a:extLst>
+          </p:cNvPr>
+          <p:cNvPicPr>
+            <a:picLocks noChangeAspect="1"/>
+          </p:cNvPicPr>
+          <p:nvPr/>
+        </p:nvPicPr>
+        <p:blipFill>
+          <a:blip r:embed="rId2">
+            <a:extLst>
+              <a:ext uri="{28A0092B-C50C-407E-A947-70E740481C1C}">
+                <a14:useLocalDpi xmlns:a14="http://schemas.microsoft.com/office/drawing/2010/main" val="0"/>
+              </a:ext>
+            </a:extLst>
+          </a:blip>
+          <a:srcRect/>
+          <a:stretch/>
+        </p:blipFill>
+        <p:spPr>
+          <a:xfrm>
+            <a:off x="2667000" y="0"/>
+            <a:ext cx="6858000" cy="6858000"/>
+          </a:xfrm>
+          <a:prstGeom prst="rect">
+            <a:avLst/>
+          </a:prstGeom>
+        </p:spPr>
+      </p:pic>
+      <p:sp>
+        <p:nvSpPr>
+          <p:cNvPr id="6" name="Rectangle 5">
+            <a:extLst>
+              <a:ext uri="{FF2B5EF4-FFF2-40B4-BE49-F238E27FC236}">
+                <a16:creationId xmlns:a16="http://schemas.microsoft.com/office/drawing/2014/main" id="{ADDF2092-2CDC-E2D6-ED59-BCAE88DA7AD2}"/>
+              </a:ext>
+            </a:extLst>
+          </p:cNvPr>
+          <p:cNvSpPr/>
+          <p:nvPr/>
+        </p:nvSpPr>
+        <p:spPr>
+          <a:xfrm>
+            <a:off x="5985163" y="519545"/>
+            <a:ext cx="405245" cy="6016337"/>
+          </a:xfrm>
+          <a:prstGeom prst="rect">
+            <a:avLst/>
+          </a:prstGeom>
+          <a:solidFill>
+            <a:schemeClr val="bg1"/>
+          </a:solidFill>
+          <a:ln>
+            <a:solidFill>
+              <a:schemeClr val="bg1"/>
+            </a:solidFill>
+          </a:ln>
+        </p:spPr>
+        <p:style>
+          <a:lnRef idx="2">
+            <a:schemeClr val="accent1">
+              <a:shade val="15000"/>
+            </a:schemeClr>
+          </a:lnRef>
+          <a:fillRef idx="1">
+            <a:schemeClr val="accent1"/>
+          </a:fillRef>
+          <a:effectRef idx="0">
+            <a:schemeClr val="accent1"/>
+          </a:effectRef>
+          <a:fontRef idx="minor">
+            <a:schemeClr val="lt1"/>
+          </a:fontRef>
+        </p:style>
+        <p:txBody>
+          <a:bodyPr rtlCol="0" anchor="ctr"/>
+          <a:lstStyle/>
+          <a:p>
+            <a:pPr algn="ctr"/>
+            <a:endParaRPr lang="en-US"/>
+          </a:p>
+        </p:txBody>
+      </p:sp>
+      <p:sp>
+        <p:nvSpPr>
+          <p:cNvPr id="8" name="Rectangle 7">
+            <a:extLst>
+              <a:ext uri="{FF2B5EF4-FFF2-40B4-BE49-F238E27FC236}">
+                <a16:creationId xmlns:a16="http://schemas.microsoft.com/office/drawing/2014/main" id="{257A9A83-F98F-9B09-81B6-C3767F37EA30}"/>
+              </a:ext>
+            </a:extLst>
+          </p:cNvPr>
+          <p:cNvSpPr/>
+          <p:nvPr/>
+        </p:nvSpPr>
+        <p:spPr>
+          <a:xfrm>
+            <a:off x="2552700" y="114299"/>
+            <a:ext cx="405245" cy="2743201"/>
+          </a:xfrm>
+          <a:prstGeom prst="rect">
+            <a:avLst/>
+          </a:prstGeom>
+          <a:solidFill>
+            <a:schemeClr val="bg1"/>
+          </a:solidFill>
+          <a:ln>
+            <a:solidFill>
+              <a:schemeClr val="bg1"/>
+            </a:solidFill>
+          </a:ln>
+        </p:spPr>
+        <p:style>
+          <a:lnRef idx="2">
+            <a:schemeClr val="accent1">
+              <a:shade val="15000"/>
+            </a:schemeClr>
+          </a:lnRef>
+          <a:fillRef idx="1">
+            <a:schemeClr val="accent1"/>
+          </a:fillRef>
+          <a:effectRef idx="0">
+            <a:schemeClr val="accent1"/>
+          </a:effectRef>
+          <a:fontRef idx="minor">
+            <a:schemeClr val="lt1"/>
+          </a:fontRef>
+        </p:style>
+        <p:txBody>
+          <a:bodyPr rtlCol="0" anchor="ctr"/>
+          <a:lstStyle/>
+          <a:p>
+            <a:pPr algn="ctr"/>
+            <a:endParaRPr lang="en-US"/>
+          </a:p>
+        </p:txBody>
+      </p:sp>
+      <p:pic>
+        <p:nvPicPr>
+          <p:cNvPr id="10" name="Picture 9">
+            <a:extLst>
+              <a:ext uri="{FF2B5EF4-FFF2-40B4-BE49-F238E27FC236}">
+                <a16:creationId xmlns:a16="http://schemas.microsoft.com/office/drawing/2014/main" id="{33C70BDB-FF8A-8FB2-77EF-52FA71B88D8E}"/>
+              </a:ext>
+            </a:extLst>
+          </p:cNvPr>
+          <p:cNvPicPr>
+            <a:picLocks noChangeAspect="1"/>
+          </p:cNvPicPr>
+          <p:nvPr/>
+        </p:nvPicPr>
+        <p:blipFill>
+          <a:blip r:embed="rId3">
+            <a:extLst>
+              <a:ext uri="{28A0092B-C50C-407E-A947-70E740481C1C}">
+                <a14:useLocalDpi xmlns:a14="http://schemas.microsoft.com/office/drawing/2010/main" val="0"/>
+              </a:ext>
+            </a:extLst>
+          </a:blip>
+          <a:srcRect l="454" t="58333" r="95354" b="11768"/>
+          <a:stretch>
+            <a:fillRect/>
+          </a:stretch>
+        </p:blipFill>
+        <p:spPr>
+          <a:xfrm>
+            <a:off x="2670461" y="519545"/>
+            <a:ext cx="287484" cy="2050473"/>
+          </a:xfrm>
+          <a:prstGeom prst="rect">
+            <a:avLst/>
+          </a:prstGeom>
+        </p:spPr>
+      </p:pic>
+      <p:sp>
+        <p:nvSpPr>
+          <p:cNvPr id="2" name="TextBox 1">
+            <a:extLst>
+              <a:ext uri="{FF2B5EF4-FFF2-40B4-BE49-F238E27FC236}">
+                <a16:creationId xmlns:a16="http://schemas.microsoft.com/office/drawing/2014/main" id="{D380F5CA-58E8-8325-CAA4-6F58C4B14C5E}"/>
+              </a:ext>
+            </a:extLst>
+          </p:cNvPr>
+          <p:cNvSpPr txBox="1"/>
+          <p:nvPr/>
+        </p:nvSpPr>
+        <p:spPr>
+          <a:xfrm>
+            <a:off x="114300" y="228600"/>
+            <a:ext cx="1143000" cy="1200329"/>
+          </a:xfrm>
+          <a:prstGeom prst="rect">
+            <a:avLst/>
+          </a:prstGeom>
+          <a:noFill/>
+        </p:spPr>
+        <p:txBody>
+          <a:bodyPr wrap="square" rtlCol="0">
+            <a:spAutoFit/>
+          </a:bodyPr>
+          <a:lstStyle/>
+          <a:p>
+            <a:r>
+              <a:rPr lang="en-US" dirty="0"/>
+              <a:t>SF3</a:t>
+            </a:r>
+          </a:p>
+          <a:p>
+            <a:r>
+              <a:rPr lang="en-US" dirty="0"/>
+              <a:t>Bobwhite</a:t>
+            </a:r>
+          </a:p>
+          <a:p>
+            <a:r>
+              <a:rPr lang="en-US" dirty="0"/>
+              <a:t>Model</a:t>
+            </a:r>
+          </a:p>
+          <a:p>
+            <a:r>
+              <a:rPr lang="en-US" dirty="0"/>
+              <a:t>Run</a:t>
+            </a:r>
+          </a:p>
+        </p:txBody>
+      </p:sp>
+    </p:spTree>
+    <p:extLst>
+      <p:ext uri="{BB962C8B-B14F-4D97-AF65-F5344CB8AC3E}">
+        <p14:creationId xmlns:p14="http://schemas.microsoft.com/office/powerpoint/2010/main" val="3461712757"/>
+      </p:ext>
+    </p:extLst>
+  </p:cSld>
+  <p:clrMapOvr>
+    <a:masterClrMapping/>
+  </p:clrMapOvr>
+</p:sld>
+</file>
+
+<file path=ppt/slides/slide7.xml><?xml version="1.0" encoding="utf-8"?>
 <p:sld xmlns:a="http://schemas.openxmlformats.org/drawingml/2006/main" xmlns:r="http://schemas.openxmlformats.org/officeDocument/2006/relationships" xmlns:p="http://schemas.openxmlformats.org/presentationml/2006/main">
   <p:cSld>
     <p:spTree>
@@ -6068,6 +6912,41 @@
           </a:prstGeom>
         </p:spPr>
       </p:pic>
+      <p:sp>
+        <p:nvSpPr>
+          <p:cNvPr id="6" name="TextBox 5">
+            <a:extLst>
+              <a:ext uri="{FF2B5EF4-FFF2-40B4-BE49-F238E27FC236}">
+                <a16:creationId xmlns:a16="http://schemas.microsoft.com/office/drawing/2014/main" id="{95A41ACD-C43A-9FFC-5499-1F1608772015}"/>
+              </a:ext>
+            </a:extLst>
+          </p:cNvPr>
+          <p:cNvSpPr txBox="1"/>
+          <p:nvPr/>
+        </p:nvSpPr>
+        <p:spPr>
+          <a:xfrm>
+            <a:off x="114300" y="228600"/>
+            <a:ext cx="1070264" cy="923330"/>
+          </a:xfrm>
+          <a:prstGeom prst="rect">
+            <a:avLst/>
+          </a:prstGeom>
+          <a:noFill/>
+        </p:spPr>
+        <p:txBody>
+          <a:bodyPr wrap="square" rtlCol="0">
+            <a:spAutoFit/>
+          </a:bodyPr>
+          <a:lstStyle/>
+          <a:p>
+            <a:r>
+              <a:rPr lang="en-US" dirty="0"/>
+              <a:t>F1 Colorful Labels</a:t>
+            </a:r>
+          </a:p>
+        </p:txBody>
+      </p:sp>
     </p:spTree>
     <p:extLst>
       <p:ext uri="{BB962C8B-B14F-4D97-AF65-F5344CB8AC3E}">
@@ -6081,7 +6960,7 @@
 </p:sld>
 </file>
 
-<file path=ppt/slides/slide7.xml><?xml version="1.0" encoding="utf-8"?>
+<file path=ppt/slides/slide8.xml><?xml version="1.0" encoding="utf-8"?>
 <p:sld xmlns:a="http://schemas.openxmlformats.org/drawingml/2006/main" xmlns:r="http://schemas.openxmlformats.org/officeDocument/2006/relationships" xmlns:p="http://schemas.openxmlformats.org/presentationml/2006/main">
   <p:cSld>
     <p:spTree>
@@ -6215,6 +7094,47 @@
           </a:prstGeom>
         </p:spPr>
       </p:pic>
+      <p:sp>
+        <p:nvSpPr>
+          <p:cNvPr id="6" name="TextBox 5">
+            <a:extLst>
+              <a:ext uri="{FF2B5EF4-FFF2-40B4-BE49-F238E27FC236}">
+                <a16:creationId xmlns:a16="http://schemas.microsoft.com/office/drawing/2014/main" id="{CE32DE9E-811C-974F-6C18-854F2C0E2482}"/>
+              </a:ext>
+            </a:extLst>
+          </p:cNvPr>
+          <p:cNvSpPr txBox="1"/>
+          <p:nvPr/>
+        </p:nvSpPr>
+        <p:spPr>
+          <a:xfrm>
+            <a:off x="114300" y="228600"/>
+            <a:ext cx="1070264" cy="923330"/>
+          </a:xfrm>
+          <a:prstGeom prst="rect">
+            <a:avLst/>
+          </a:prstGeom>
+          <a:noFill/>
+        </p:spPr>
+        <p:txBody>
+          <a:bodyPr wrap="square" rtlCol="0">
+            <a:spAutoFit/>
+          </a:bodyPr>
+          <a:lstStyle/>
+          <a:p>
+            <a:r>
+              <a:rPr lang="en-US" dirty="0"/>
+              <a:t>F1 </a:t>
+            </a:r>
+          </a:p>
+          <a:p>
+            <a:r>
+              <a:rPr lang="en-US" dirty="0"/>
+              <a:t>Black Labels</a:t>
+            </a:r>
+          </a:p>
+        </p:txBody>
+      </p:sp>
     </p:spTree>
     <p:extLst>
       <p:ext uri="{BB962C8B-B14F-4D97-AF65-F5344CB8AC3E}">

</xml_diff>

<commit_message>
87% CI population trends
</commit_message>
<xml_diff>
--- a/figures/ch1/ch1_figures.pptx
+++ b/figures/ch1/ch1_figures.pptx
@@ -266,7 +266,7 @@
           <a:p>
             <a:fld id="{6AECCEE4-E404-41DF-89A3-E64313283A40}" type="datetimeFigureOut">
               <a:rPr lang="en-US" smtClean="0"/>
-              <a:t>7/7/2026</a:t>
+              <a:t>7/16/2026</a:t>
             </a:fld>
             <a:endParaRPr lang="en-US"/>
           </a:p>
@@ -464,7 +464,7 @@
           <a:p>
             <a:fld id="{6AECCEE4-E404-41DF-89A3-E64313283A40}" type="datetimeFigureOut">
               <a:rPr lang="en-US" smtClean="0"/>
-              <a:t>7/7/2026</a:t>
+              <a:t>7/16/2026</a:t>
             </a:fld>
             <a:endParaRPr lang="en-US"/>
           </a:p>
@@ -672,7 +672,7 @@
           <a:p>
             <a:fld id="{6AECCEE4-E404-41DF-89A3-E64313283A40}" type="datetimeFigureOut">
               <a:rPr lang="en-US" smtClean="0"/>
-              <a:t>7/7/2026</a:t>
+              <a:t>7/16/2026</a:t>
             </a:fld>
             <a:endParaRPr lang="en-US"/>
           </a:p>
@@ -870,7 +870,7 @@
           <a:p>
             <a:fld id="{6AECCEE4-E404-41DF-89A3-E64313283A40}" type="datetimeFigureOut">
               <a:rPr lang="en-US" smtClean="0"/>
-              <a:t>7/7/2026</a:t>
+              <a:t>7/16/2026</a:t>
             </a:fld>
             <a:endParaRPr lang="en-US"/>
           </a:p>
@@ -1145,7 +1145,7 @@
           <a:p>
             <a:fld id="{6AECCEE4-E404-41DF-89A3-E64313283A40}" type="datetimeFigureOut">
               <a:rPr lang="en-US" smtClean="0"/>
-              <a:t>7/7/2026</a:t>
+              <a:t>7/16/2026</a:t>
             </a:fld>
             <a:endParaRPr lang="en-US"/>
           </a:p>
@@ -1410,7 +1410,7 @@
           <a:p>
             <a:fld id="{6AECCEE4-E404-41DF-89A3-E64313283A40}" type="datetimeFigureOut">
               <a:rPr lang="en-US" smtClean="0"/>
-              <a:t>7/7/2026</a:t>
+              <a:t>7/16/2026</a:t>
             </a:fld>
             <a:endParaRPr lang="en-US"/>
           </a:p>
@@ -1822,7 +1822,7 @@
           <a:p>
             <a:fld id="{6AECCEE4-E404-41DF-89A3-E64313283A40}" type="datetimeFigureOut">
               <a:rPr lang="en-US" smtClean="0"/>
-              <a:t>7/7/2026</a:t>
+              <a:t>7/16/2026</a:t>
             </a:fld>
             <a:endParaRPr lang="en-US"/>
           </a:p>
@@ -1963,7 +1963,7 @@
           <a:p>
             <a:fld id="{6AECCEE4-E404-41DF-89A3-E64313283A40}" type="datetimeFigureOut">
               <a:rPr lang="en-US" smtClean="0"/>
-              <a:t>7/7/2026</a:t>
+              <a:t>7/16/2026</a:t>
             </a:fld>
             <a:endParaRPr lang="en-US"/>
           </a:p>
@@ -2076,7 +2076,7 @@
           <a:p>
             <a:fld id="{6AECCEE4-E404-41DF-89A3-E64313283A40}" type="datetimeFigureOut">
               <a:rPr lang="en-US" smtClean="0"/>
-              <a:t>7/7/2026</a:t>
+              <a:t>7/16/2026</a:t>
             </a:fld>
             <a:endParaRPr lang="en-US"/>
           </a:p>
@@ -2387,7 +2387,7 @@
           <a:p>
             <a:fld id="{6AECCEE4-E404-41DF-89A3-E64313283A40}" type="datetimeFigureOut">
               <a:rPr lang="en-US" smtClean="0"/>
-              <a:t>7/7/2026</a:t>
+              <a:t>7/16/2026</a:t>
             </a:fld>
             <a:endParaRPr lang="en-US"/>
           </a:p>
@@ -2675,7 +2675,7 @@
           <a:p>
             <a:fld id="{6AECCEE4-E404-41DF-89A3-E64313283A40}" type="datetimeFigureOut">
               <a:rPr lang="en-US" smtClean="0"/>
-              <a:t>7/7/2026</a:t>
+              <a:t>7/16/2026</a:t>
             </a:fld>
             <a:endParaRPr lang="en-US"/>
           </a:p>
@@ -2916,7 +2916,7 @@
           <a:p>
             <a:fld id="{6AECCEE4-E404-41DF-89A3-E64313283A40}" type="datetimeFigureOut">
               <a:rPr lang="en-US" smtClean="0"/>
-              <a:t>7/7/2026</a:t>
+              <a:t>7/16/2026</a:t>
             </a:fld>
             <a:endParaRPr lang="en-US"/>
           </a:p>

</xml_diff>